<commit_message>
Update HRV presentation: modify content for improved clarity and engagement
</commit_message>
<xml_diff>
--- a/HRV_Praesentation_korrigiert.pptx
+++ b/HRV_Praesentation_korrigiert.pptx
@@ -5,7 +5,7 @@
     <p:sldMasterId id="2147483648" r:id="rId1"/>
   </p:sldMasterIdLst>
   <p:notesMasterIdLst>
-    <p:notesMasterId r:id="rId10"/>
+    <p:notesMasterId r:id="rId11"/>
   </p:notesMasterIdLst>
   <p:sldIdLst>
     <p:sldId id="256" r:id="rId2"/>
@@ -14,8 +14,9 @@
     <p:sldId id="259" r:id="rId5"/>
     <p:sldId id="260" r:id="rId6"/>
     <p:sldId id="261" r:id="rId7"/>
-    <p:sldId id="262" r:id="rId8"/>
-    <p:sldId id="263" r:id="rId9"/>
+    <p:sldId id="264" r:id="rId8"/>
+    <p:sldId id="262" r:id="rId9"/>
+    <p:sldId id="263" r:id="rId10"/>
   </p:sldIdLst>
   <p:sldSz cx="12192000" cy="6858000"/>
   <p:notesSz cx="6858000" cy="9144000"/>
@@ -2084,6 +2085,128 @@
   <p:cSld>
     <p:spTree>
       <p:nvGrpSpPr>
+        <p:cNvPr id="1" name="">
+          <a:extLst>
+            <a:ext uri="{FF2B5EF4-FFF2-40B4-BE49-F238E27FC236}">
+              <a16:creationId xmlns:a16="http://schemas.microsoft.com/office/drawing/2014/main" id="{9F9DA5B4-0AC9-F690-41B6-F869520B8462}"/>
+            </a:ext>
+          </a:extLst>
+        </p:cNvPr>
+        <p:cNvGrpSpPr/>
+        <p:nvPr/>
+      </p:nvGrpSpPr>
+      <p:grpSpPr>
+        <a:xfrm>
+          <a:off x="0" y="0"/>
+          <a:ext cx="0" cy="0"/>
+          <a:chOff x="0" y="0"/>
+          <a:chExt cx="0" cy="0"/>
+        </a:xfrm>
+      </p:grpSpPr>
+      <p:sp>
+        <p:nvSpPr>
+          <p:cNvPr id="2" name="Slide Image Placeholder 1">
+            <a:extLst>
+              <a:ext uri="{FF2B5EF4-FFF2-40B4-BE49-F238E27FC236}">
+                <a16:creationId xmlns:a16="http://schemas.microsoft.com/office/drawing/2014/main" id="{4886FF11-EA9D-9F11-3629-CB4ED37F37A5}"/>
+              </a:ext>
+            </a:extLst>
+          </p:cNvPr>
+          <p:cNvSpPr>
+            <a:spLocks noGrp="1" noRot="1" noChangeAspect="1"/>
+          </p:cNvSpPr>
+          <p:nvPr>
+            <p:ph type="sldImg" idx="2"/>
+          </p:nvPr>
+        </p:nvSpPr>
+        <p:spPr/>
+      </p:sp>
+      <p:sp>
+        <p:nvSpPr>
+          <p:cNvPr id="3" name="Notes Placeholder 2">
+            <a:extLst>
+              <a:ext uri="{FF2B5EF4-FFF2-40B4-BE49-F238E27FC236}">
+                <a16:creationId xmlns:a16="http://schemas.microsoft.com/office/drawing/2014/main" id="{E3C9A8CA-47FC-1B7E-89E4-7CD6213118BF}"/>
+              </a:ext>
+            </a:extLst>
+          </p:cNvPr>
+          <p:cNvSpPr>
+            <a:spLocks noGrp="1"/>
+          </p:cNvSpPr>
+          <p:nvPr>
+            <p:ph type="body" sz="quarter" idx="3"/>
+          </p:nvPr>
+        </p:nvSpPr>
+        <p:spPr/>
+        <p:txBody>
+          <a:bodyPr/>
+          <a:lstStyle/>
+          <a:p>
+            <a:r>
+              <a:t>(ca. 6:45–7:30) Die Kernaussage in einem Satz.</a:t>
+            </a:r>
+          </a:p>
+          <a:p>
+            <a:endParaRPr/>
+          </a:p>
+          <a:p>
+            <a:r>
+              <a:t>• Das HRV-Signal hat starke langsame und nur schwache schnelle Anteile.</a:t>
+            </a:r>
+          </a:p>
+          <a:p>
+            <a:r>
+              <a:t>• Das Rechteck lässt die starke langsame Energie ins HF-Band lecken → HF wird ~4× zu groß.</a:t>
+            </a:r>
+          </a:p>
+          <a:p>
+            <a:r>
+              <a:t>• Damit kippt auch LF/HF – und das ist eine Zahl, die man medizinisch interpretiert.</a:t>
+            </a:r>
+          </a:p>
+          <a:p>
+            <a:r>
+              <a:t>• Botschaft: Die Fensterwahl ist keine Kosmetik, sie ändert das Ergebnis.</a:t>
+            </a:r>
+          </a:p>
+        </p:txBody>
+      </p:sp>
+      <p:sp>
+        <p:nvSpPr>
+          <p:cNvPr id="4" name="Slide Number Placeholder 3">
+            <a:extLst>
+              <a:ext uri="{FF2B5EF4-FFF2-40B4-BE49-F238E27FC236}">
+                <a16:creationId xmlns:a16="http://schemas.microsoft.com/office/drawing/2014/main" id="{C9FACF31-6DB6-8317-DE2E-629EDF20AA16}"/>
+              </a:ext>
+            </a:extLst>
+          </p:cNvPr>
+          <p:cNvSpPr>
+            <a:spLocks noGrp="1"/>
+          </p:cNvSpPr>
+          <p:nvPr>
+            <p:ph type="sldNum" sz="quarter" idx="5"/>
+          </p:nvPr>
+        </p:nvSpPr>
+        <p:spPr/>
+      </p:sp>
+    </p:spTree>
+    <p:extLst>
+      <p:ext uri="{BB962C8B-B14F-4D97-AF65-F5344CB8AC3E}">
+        <p14:creationId xmlns:p14="http://schemas.microsoft.com/office/powerpoint/2010/main" val="3803645230"/>
+      </p:ext>
+    </p:extLst>
+  </p:cSld>
+  <p:clrMapOvr>
+    <a:masterClrMapping/>
+  </p:clrMapOvr>
+</p:notes>
+</file>
+
+<file path=ppt/notesSlides/notesSlide8.xml><?xml version="1.0" encoding="utf-8"?>
+<p:notes xmlns:a="http://schemas.openxmlformats.org/drawingml/2006/main" xmlns:r="http://schemas.openxmlformats.org/officeDocument/2006/relationships" xmlns:p="http://schemas.openxmlformats.org/presentationml/2006/main">
+  <p:cSld>
+    <p:spTree>
+      <p:nvGrpSpPr>
         <p:cNvPr id="1" name=""/>
         <p:cNvGrpSpPr/>
         <p:nvPr/>
@@ -2259,7 +2382,7 @@
 </p:notes>
 </file>
 
-<file path=ppt/notesSlides/notesSlide8.xml><?xml version="1.0" encoding="utf-8"?>
+<file path=ppt/notesSlides/notesSlide9.xml><?xml version="1.0" encoding="utf-8"?>
 <p:notes xmlns:a="http://schemas.openxmlformats.org/drawingml/2006/main" xmlns:r="http://schemas.openxmlformats.org/officeDocument/2006/relationships" xmlns:p="http://schemas.openxmlformats.org/presentationml/2006/main">
   <p:cSld>
     <p:spTree>
@@ -9669,7 +9792,7 @@
               </a:spcAft>
             </a:pPr>
             <a:r>
-              <a:rPr sz="3000" b="1" i="0">
+              <a:rPr lang="de-DE" sz="3000" b="1" i="0" noProof="0" dirty="0">
                 <a:solidFill>
                   <a:srgbClr val="1A2332"/>
                 </a:solidFill>
@@ -9721,7 +9844,7 @@
           <a:lstStyle/>
           <a:p>
             <a:pPr algn="ctr"/>
-            <a:endParaRPr/>
+            <a:endParaRPr lang="de-DE" noProof="0" dirty="0"/>
           </a:p>
         </p:txBody>
       </p:sp>
@@ -9734,7 +9857,7 @@
         <p:spPr>
           <a:xfrm>
             <a:off x="822960" y="1920240"/>
-            <a:ext cx="10607040" cy="2569934"/>
+            <a:ext cx="10607040" cy="3231654"/>
           </a:xfrm>
           <a:prstGeom prst="rect">
             <a:avLst/>
@@ -9756,97 +9879,16 @@
               </a:spcAft>
             </a:pPr>
             <a:r>
-              <a:rPr sz="2100" b="0" i="0" dirty="0">
+              <a:rPr lang="de-DE" sz="2100" b="0" i="0" noProof="0" dirty="0">
                 <a:solidFill>
                   <a:srgbClr val="1A2332"/>
                 </a:solidFill>
                 <a:latin typeface="Arial"/>
               </a:rPr>
-              <a:t>Das Herz </a:t>
-            </a:r>
-            <a:r>
-              <a:rPr sz="2100" b="0" i="0" dirty="0" err="1">
-                <a:solidFill>
-                  <a:srgbClr val="1A2332"/>
-                </a:solidFill>
-                <a:latin typeface="Arial"/>
-              </a:rPr>
-              <a:t>schlägt</a:t>
-            </a:r>
-            <a:r>
-              <a:rPr sz="2100" b="0" i="0" dirty="0">
-                <a:solidFill>
-                  <a:srgbClr val="1A2332"/>
-                </a:solidFill>
-                <a:latin typeface="Arial"/>
-              </a:rPr>
-              <a:t> </a:t>
-            </a:r>
-            <a:r>
-              <a:rPr sz="2100" b="0" i="0" dirty="0" err="1">
-                <a:solidFill>
-                  <a:srgbClr val="1A2332"/>
-                </a:solidFill>
-                <a:latin typeface="Arial"/>
-              </a:rPr>
-              <a:t>nie</a:t>
-            </a:r>
-            <a:r>
-              <a:rPr sz="2100" b="0" i="0" dirty="0">
-                <a:solidFill>
-                  <a:srgbClr val="1A2332"/>
-                </a:solidFill>
-                <a:latin typeface="Arial"/>
-              </a:rPr>
-              <a:t> </a:t>
-            </a:r>
-            <a:r>
-              <a:rPr sz="2100" b="0" i="0" dirty="0" err="1">
-                <a:solidFill>
-                  <a:srgbClr val="1A2332"/>
-                </a:solidFill>
-                <a:latin typeface="Arial"/>
-              </a:rPr>
-              <a:t>exakt</a:t>
-            </a:r>
-            <a:r>
-              <a:rPr sz="2100" b="0" i="0" dirty="0">
-                <a:solidFill>
-                  <a:srgbClr val="1A2332"/>
-                </a:solidFill>
-                <a:latin typeface="Arial"/>
-              </a:rPr>
-              <a:t> </a:t>
-            </a:r>
-            <a:r>
-              <a:rPr sz="2100" b="0" i="0" dirty="0" err="1">
-                <a:solidFill>
-                  <a:srgbClr val="1A2332"/>
-                </a:solidFill>
-                <a:latin typeface="Arial"/>
-              </a:rPr>
-              <a:t>gleichmäßig</a:t>
-            </a:r>
-            <a:r>
-              <a:rPr lang="de-DE" sz="2100" b="0" i="0" dirty="0">
-                <a:solidFill>
-                  <a:srgbClr val="1A2332"/>
-                </a:solidFill>
-                <a:latin typeface="Arial"/>
-              </a:rPr>
-              <a:t>.</a:t>
-            </a:r>
-            <a:r>
-              <a:rPr sz="2100" b="0" i="0" dirty="0">
-                <a:solidFill>
-                  <a:srgbClr val="1A2332"/>
-                </a:solidFill>
-                <a:latin typeface="Arial"/>
-              </a:rPr>
-              <a:t> </a:t>
-            </a:r>
-            <a:r>
-              <a:rPr lang="de-DE" sz="2100" dirty="0">
+              <a:t>Das Herz schlägt nie exakt gleichmäßig. </a:t>
+            </a:r>
+            <a:r>
+              <a:rPr lang="de-DE" sz="2100" noProof="0" dirty="0">
                 <a:solidFill>
                   <a:srgbClr val="1A2332"/>
                 </a:solidFill>
@@ -9855,139 +9897,13 @@
               <a:t>I</a:t>
             </a:r>
             <a:r>
-              <a:rPr sz="2100" b="0" i="0" dirty="0">
+              <a:rPr lang="de-DE" sz="2100" b="0" i="0" noProof="0" dirty="0">
                 <a:solidFill>
                   <a:srgbClr val="1A2332"/>
                 </a:solidFill>
                 <a:latin typeface="Arial"/>
               </a:rPr>
-              <a:t>n den </a:t>
-            </a:r>
-            <a:r>
-              <a:rPr sz="2100" b="0" i="0" dirty="0" err="1">
-                <a:solidFill>
-                  <a:srgbClr val="1A2332"/>
-                </a:solidFill>
-                <a:latin typeface="Arial"/>
-              </a:rPr>
-              <a:t>kleinen</a:t>
-            </a:r>
-            <a:r>
-              <a:rPr sz="2100" b="0" i="0" dirty="0">
-                <a:solidFill>
-                  <a:srgbClr val="1A2332"/>
-                </a:solidFill>
-                <a:latin typeface="Arial"/>
-              </a:rPr>
-              <a:t> </a:t>
-            </a:r>
-            <a:r>
-              <a:rPr sz="2100" b="0" i="0" dirty="0" err="1">
-                <a:solidFill>
-                  <a:srgbClr val="1A2332"/>
-                </a:solidFill>
-                <a:latin typeface="Arial"/>
-              </a:rPr>
-              <a:t>Schwankungen</a:t>
-            </a:r>
-            <a:r>
-              <a:rPr sz="2100" b="0" i="0" dirty="0">
-                <a:solidFill>
-                  <a:srgbClr val="1A2332"/>
-                </a:solidFill>
-                <a:latin typeface="Arial"/>
-              </a:rPr>
-              <a:t> der </a:t>
-            </a:r>
-            <a:r>
-              <a:rPr sz="2100" b="0" i="0" dirty="0" err="1">
-                <a:solidFill>
-                  <a:srgbClr val="1A2332"/>
-                </a:solidFill>
-                <a:latin typeface="Arial"/>
-              </a:rPr>
-              <a:t>Schlagabstände</a:t>
-            </a:r>
-            <a:r>
-              <a:rPr sz="2100" b="0" i="0" dirty="0">
-                <a:solidFill>
-                  <a:srgbClr val="1A2332"/>
-                </a:solidFill>
-                <a:latin typeface="Arial"/>
-              </a:rPr>
-              <a:t> </a:t>
-            </a:r>
-            <a:r>
-              <a:rPr sz="2100" b="0" i="0" dirty="0" err="1">
-                <a:solidFill>
-                  <a:srgbClr val="1A2332"/>
-                </a:solidFill>
-                <a:latin typeface="Arial"/>
-              </a:rPr>
-              <a:t>stecken</a:t>
-            </a:r>
-            <a:r>
-              <a:rPr sz="2100" b="0" i="0" dirty="0">
-                <a:solidFill>
-                  <a:srgbClr val="1A2332"/>
-                </a:solidFill>
-                <a:latin typeface="Arial"/>
-              </a:rPr>
-              <a:t> </a:t>
-            </a:r>
-            <a:r>
-              <a:rPr sz="2100" b="0" i="0" dirty="0" err="1">
-                <a:solidFill>
-                  <a:srgbClr val="1A2332"/>
-                </a:solidFill>
-                <a:latin typeface="Arial"/>
-              </a:rPr>
-              <a:t>Rhythmen</a:t>
-            </a:r>
-            <a:r>
-              <a:rPr sz="2100" b="0" i="0" dirty="0">
-                <a:solidFill>
-                  <a:srgbClr val="1A2332"/>
-                </a:solidFill>
-                <a:latin typeface="Arial"/>
-              </a:rPr>
-              <a:t> (</a:t>
-            </a:r>
-            <a:r>
-              <a:rPr sz="2100" b="0" i="0" dirty="0" err="1">
-                <a:solidFill>
-                  <a:srgbClr val="1A2332"/>
-                </a:solidFill>
-                <a:latin typeface="Arial"/>
-              </a:rPr>
-              <a:t>Atmung</a:t>
-            </a:r>
-            <a:r>
-              <a:rPr sz="2100" b="0" i="0" dirty="0">
-                <a:solidFill>
-                  <a:srgbClr val="1A2332"/>
-                </a:solidFill>
-                <a:latin typeface="Arial"/>
-              </a:rPr>
-              <a:t>, </a:t>
-            </a:r>
-            <a:r>
-              <a:rPr sz="2100" b="0" i="0" dirty="0" err="1">
-                <a:solidFill>
-                  <a:srgbClr val="1A2332"/>
-                </a:solidFill>
-                <a:latin typeface="Arial"/>
-              </a:rPr>
-              <a:t>Blutdruck­regelung</a:t>
-            </a:r>
-            <a:r>
-              <a:rPr sz="2100" b="0" i="0" dirty="0">
-                <a:solidFill>
-                  <a:srgbClr val="1A2332"/>
-                </a:solidFill>
-                <a:latin typeface="Arial"/>
-              </a:rPr>
-              <a:t>).</a:t>
+              <a:t>n den kleinen Schwankungen der Schlagabstände stecken Rhythmen (Atmung, Blutdruck­regelung).</a:t>
             </a:r>
           </a:p>
           <a:p>
@@ -10000,115 +9916,16 @@
               </a:spcAft>
             </a:pPr>
             <a:r>
-              <a:rPr sz="2100" b="0" i="0" dirty="0">
+              <a:rPr lang="de-DE" sz="2100" b="0" i="0" noProof="0" dirty="0">
                 <a:solidFill>
                   <a:srgbClr val="1A2332"/>
                 </a:solidFill>
                 <a:latin typeface="Arial"/>
               </a:rPr>
-              <a:t>Die FFT </a:t>
-            </a:r>
-            <a:r>
-              <a:rPr sz="2100" b="0" i="0" dirty="0" err="1">
-                <a:solidFill>
-                  <a:srgbClr val="1A2332"/>
-                </a:solidFill>
-                <a:latin typeface="Arial"/>
-              </a:rPr>
-              <a:t>macht</a:t>
-            </a:r>
-            <a:r>
-              <a:rPr sz="2100" b="0" i="0" dirty="0">
-                <a:solidFill>
-                  <a:srgbClr val="1A2332"/>
-                </a:solidFill>
-                <a:latin typeface="Arial"/>
-              </a:rPr>
-              <a:t> </a:t>
-            </a:r>
-            <a:r>
-              <a:rPr sz="2100" b="0" i="0" dirty="0" err="1">
-                <a:solidFill>
-                  <a:srgbClr val="1A2332"/>
-                </a:solidFill>
-                <a:latin typeface="Arial"/>
-              </a:rPr>
-              <a:t>diese</a:t>
-            </a:r>
-            <a:r>
-              <a:rPr sz="2100" b="0" i="0" dirty="0">
-                <a:solidFill>
-                  <a:srgbClr val="1A2332"/>
-                </a:solidFill>
-                <a:latin typeface="Arial"/>
-              </a:rPr>
-              <a:t> </a:t>
-            </a:r>
-            <a:r>
-              <a:rPr sz="2100" b="0" i="0" dirty="0" err="1">
-                <a:solidFill>
-                  <a:srgbClr val="1A2332"/>
-                </a:solidFill>
-                <a:latin typeface="Arial"/>
-              </a:rPr>
-              <a:t>Rhythmen</a:t>
-            </a:r>
-            <a:r>
-              <a:rPr sz="2100" b="0" i="0" dirty="0">
-                <a:solidFill>
-                  <a:srgbClr val="1A2332"/>
-                </a:solidFill>
-                <a:latin typeface="Arial"/>
-              </a:rPr>
-              <a:t> </a:t>
-            </a:r>
-            <a:r>
-              <a:rPr sz="2100" b="0" i="0" dirty="0" err="1">
-                <a:solidFill>
-                  <a:srgbClr val="1A2332"/>
-                </a:solidFill>
-                <a:latin typeface="Arial"/>
-              </a:rPr>
-              <a:t>als</a:t>
-            </a:r>
-            <a:r>
-              <a:rPr sz="2100" b="0" i="0" dirty="0">
-                <a:solidFill>
-                  <a:srgbClr val="1A2332"/>
-                </a:solidFill>
-                <a:latin typeface="Arial"/>
-              </a:rPr>
-              <a:t> </a:t>
-            </a:r>
-            <a:r>
-              <a:rPr sz="2100" b="0" i="0" dirty="0" err="1">
-                <a:solidFill>
-                  <a:srgbClr val="1A2332"/>
-                </a:solidFill>
-                <a:latin typeface="Arial"/>
-              </a:rPr>
-              <a:t>Frequenzen</a:t>
-            </a:r>
-            <a:r>
-              <a:rPr sz="2100" b="0" i="0" dirty="0">
-                <a:solidFill>
-                  <a:srgbClr val="1A2332"/>
-                </a:solidFill>
-                <a:latin typeface="Arial"/>
-              </a:rPr>
-              <a:t> </a:t>
-            </a:r>
-            <a:r>
-              <a:rPr sz="2100" b="0" i="0" dirty="0" err="1">
-                <a:solidFill>
-                  <a:srgbClr val="1A2332"/>
-                </a:solidFill>
-                <a:latin typeface="Arial"/>
-              </a:rPr>
-              <a:t>sichtbar</a:t>
-            </a:r>
-            <a:r>
-              <a:rPr lang="de-DE" sz="2100" dirty="0">
+              <a:t>Die FFT macht diese Rhythmen als Frequenzen sichtbar</a:t>
+            </a:r>
+            <a:r>
+              <a:rPr lang="de-DE" sz="2100" noProof="0" dirty="0">
                 <a:solidFill>
                   <a:srgbClr val="1A2332"/>
                 </a:solidFill>
@@ -10117,139 +9934,31 @@
               <a:t>,</a:t>
             </a:r>
             <a:r>
-              <a:rPr sz="2100" b="0" i="0" dirty="0">
+              <a:rPr lang="de-DE" sz="2100" b="0" i="0" noProof="0" dirty="0">
                 <a:solidFill>
                   <a:srgbClr val="1A2332"/>
                 </a:solidFill>
                 <a:latin typeface="Arial"/>
               </a:rPr>
-              <a:t> </a:t>
-            </a:r>
-            <a:r>
-              <a:rPr sz="2100" b="0" i="0" dirty="0" err="1">
+              <a:t> aber ein endlicher Signalausschnitt erzeugt „</a:t>
+            </a:r>
+            <a:r>
+              <a:rPr lang="de-DE" sz="2100" b="0" i="0" noProof="0" dirty="0" err="1">
                 <a:solidFill>
                   <a:srgbClr val="1A2332"/>
                 </a:solidFill>
                 <a:latin typeface="Arial"/>
               </a:rPr>
-              <a:t>aber</a:t>
-            </a:r>
-            <a:r>
-              <a:rPr sz="2100" b="0" i="0" dirty="0">
+              <a:t>Spectral</a:t>
+            </a:r>
+            <a:r>
+              <a:rPr lang="de-DE" sz="2100" b="0" i="0" noProof="0" dirty="0">
                 <a:solidFill>
                   <a:srgbClr val="1A2332"/>
                 </a:solidFill>
                 <a:latin typeface="Arial"/>
               </a:rPr>
-              <a:t> </a:t>
-            </a:r>
-            <a:r>
-              <a:rPr sz="2100" b="0" i="0" dirty="0" err="1">
-                <a:solidFill>
-                  <a:srgbClr val="1A2332"/>
-                </a:solidFill>
-                <a:latin typeface="Arial"/>
-              </a:rPr>
-              <a:t>ein</a:t>
-            </a:r>
-            <a:r>
-              <a:rPr sz="2100" b="0" i="0" dirty="0">
-                <a:solidFill>
-                  <a:srgbClr val="1A2332"/>
-                </a:solidFill>
-                <a:latin typeface="Arial"/>
-              </a:rPr>
-              <a:t> </a:t>
-            </a:r>
-            <a:r>
-              <a:rPr sz="2100" b="0" i="0" dirty="0" err="1">
-                <a:solidFill>
-                  <a:srgbClr val="1A2332"/>
-                </a:solidFill>
-                <a:latin typeface="Arial"/>
-              </a:rPr>
-              <a:t>endlicher</a:t>
-            </a:r>
-            <a:r>
-              <a:rPr sz="2100" b="0" i="0" dirty="0">
-                <a:solidFill>
-                  <a:srgbClr val="1A2332"/>
-                </a:solidFill>
-                <a:latin typeface="Arial"/>
-              </a:rPr>
-              <a:t> </a:t>
-            </a:r>
-            <a:r>
-              <a:rPr sz="2100" b="0" i="0" dirty="0" err="1">
-                <a:solidFill>
-                  <a:srgbClr val="1A2332"/>
-                </a:solidFill>
-                <a:latin typeface="Arial"/>
-              </a:rPr>
-              <a:t>Signalausschnitt</a:t>
-            </a:r>
-            <a:r>
-              <a:rPr sz="2100" b="0" i="0" dirty="0">
-                <a:solidFill>
-                  <a:srgbClr val="1A2332"/>
-                </a:solidFill>
-                <a:latin typeface="Arial"/>
-              </a:rPr>
-              <a:t> </a:t>
-            </a:r>
-            <a:r>
-              <a:rPr sz="2100" b="0" i="0" dirty="0" err="1">
-                <a:solidFill>
-                  <a:srgbClr val="1A2332"/>
-                </a:solidFill>
-                <a:latin typeface="Arial"/>
-              </a:rPr>
-              <a:t>erzeugt</a:t>
-            </a:r>
-            <a:r>
-              <a:rPr sz="2100" b="0" i="0" dirty="0">
-                <a:solidFill>
-                  <a:srgbClr val="1A2332"/>
-                </a:solidFill>
-                <a:latin typeface="Arial"/>
-              </a:rPr>
-              <a:t> „Spectral Leakage“, das die </a:t>
-            </a:r>
-            <a:r>
-              <a:rPr sz="2100" b="0" i="0" dirty="0" err="1">
-                <a:solidFill>
-                  <a:srgbClr val="1A2332"/>
-                </a:solidFill>
-                <a:latin typeface="Arial"/>
-              </a:rPr>
-              <a:t>Werte</a:t>
-            </a:r>
-            <a:r>
-              <a:rPr sz="2100" b="0" i="0" dirty="0">
-                <a:solidFill>
-                  <a:srgbClr val="1A2332"/>
-                </a:solidFill>
-                <a:latin typeface="Arial"/>
-              </a:rPr>
-              <a:t> </a:t>
-            </a:r>
-            <a:r>
-              <a:rPr sz="2100" b="0" i="0" dirty="0" err="1">
-                <a:solidFill>
-                  <a:srgbClr val="1A2332"/>
-                </a:solidFill>
-                <a:latin typeface="Arial"/>
-              </a:rPr>
-              <a:t>verfälscht</a:t>
-            </a:r>
-            <a:r>
-              <a:rPr sz="2100" b="0" i="0" dirty="0">
-                <a:solidFill>
-                  <a:srgbClr val="1A2332"/>
-                </a:solidFill>
-                <a:latin typeface="Arial"/>
-              </a:rPr>
-              <a:t>.</a:t>
+              <a:t> Leakage“, das die Werte verfälscht.</a:t>
             </a:r>
           </a:p>
           <a:p>
@@ -10262,40 +9971,13 @@
               </a:spcAft>
             </a:pPr>
             <a:r>
-              <a:rPr sz="2100" b="0" i="0" dirty="0" err="1">
+              <a:rPr lang="de-DE" sz="2100" b="0" i="0" noProof="0" dirty="0">
                 <a:solidFill>
                   <a:srgbClr val="1A2332"/>
                 </a:solidFill>
                 <a:latin typeface="Arial"/>
               </a:rPr>
-              <a:t>Fensterfunktionen</a:t>
-            </a:r>
-            <a:r>
-              <a:rPr sz="2100" b="0" i="0" dirty="0">
-                <a:solidFill>
-                  <a:srgbClr val="1A2332"/>
-                </a:solidFill>
-                <a:latin typeface="Arial"/>
-              </a:rPr>
-              <a:t> </a:t>
-            </a:r>
-            <a:r>
-              <a:rPr sz="2100" b="0" i="0" dirty="0" err="1">
-                <a:solidFill>
-                  <a:srgbClr val="1A2332"/>
-                </a:solidFill>
-                <a:latin typeface="Arial"/>
-              </a:rPr>
-              <a:t>dämpfen</a:t>
-            </a:r>
-            <a:r>
-              <a:rPr sz="2100" b="0" i="0" dirty="0">
-                <a:solidFill>
-                  <a:srgbClr val="1A2332"/>
-                </a:solidFill>
-                <a:latin typeface="Arial"/>
-              </a:rPr>
-              <a:t> dieses Leakage.</a:t>
+              <a:t>Fensterfunktionen dämpfen dieses Leakage, verbreitern jedoch die Hauptkeule und verschlechtern damit die Frequenzauflösung.</a:t>
             </a:r>
           </a:p>
           <a:p>
@@ -10307,86 +9989,39 @@
                 <a:spcPts val="0"/>
               </a:spcAft>
             </a:pPr>
-            <a:r>
-              <a:rPr sz="2200" b="1" i="0" dirty="0">
+            <a:endParaRPr lang="de-DE" sz="2200" b="1" i="0" noProof="0" dirty="0">
+              <a:solidFill>
+                <a:srgbClr val="D62828"/>
+              </a:solidFill>
+              <a:latin typeface="Arial"/>
+            </a:endParaRPr>
+          </a:p>
+          <a:p>
+            <a:pPr algn="l">
+              <a:spcBef>
+                <a:spcPts val="0"/>
+              </a:spcBef>
+              <a:spcAft>
+                <a:spcPts val="0"/>
+              </a:spcAft>
+            </a:pPr>
+            <a:r>
+              <a:rPr lang="de-DE" sz="2200" b="1" i="0" noProof="0">
                 <a:solidFill>
                   <a:srgbClr val="D62828"/>
                 </a:solidFill>
                 <a:latin typeface="Arial"/>
               </a:rPr>
-              <a:t>→  </a:t>
-            </a:r>
-            <a:r>
-              <a:rPr lang="de-DE" sz="2200" b="1" i="0" dirty="0">
+              <a:t>→  Welches </a:t>
+            </a:r>
+            <a:r>
+              <a:rPr lang="de-DE" sz="2200" b="1" i="0" noProof="0" dirty="0">
                 <a:solidFill>
                   <a:srgbClr val="D62828"/>
                 </a:solidFill>
                 <a:latin typeface="Arial"/>
               </a:rPr>
-              <a:t>Aufgabenstellung</a:t>
-            </a:r>
-            <a:r>
-              <a:rPr sz="2200" b="1" i="0" dirty="0">
-                <a:solidFill>
-                  <a:srgbClr val="D62828"/>
-                </a:solidFill>
-                <a:latin typeface="Arial"/>
-              </a:rPr>
-              <a:t>: Welches Fenster </a:t>
-            </a:r>
-            <a:r>
-              <a:rPr sz="2200" b="1" i="0" dirty="0" err="1">
-                <a:solidFill>
-                  <a:srgbClr val="D62828"/>
-                </a:solidFill>
-                <a:latin typeface="Arial"/>
-              </a:rPr>
-              <a:t>ist</a:t>
-            </a:r>
-            <a:r>
-              <a:rPr sz="2200" b="1" i="0" dirty="0">
-                <a:solidFill>
-                  <a:srgbClr val="D62828"/>
-                </a:solidFill>
-                <a:latin typeface="Arial"/>
-              </a:rPr>
-              <a:t> der </a:t>
-            </a:r>
-            <a:r>
-              <a:rPr sz="2200" b="1" i="0" dirty="0" err="1">
-                <a:solidFill>
-                  <a:srgbClr val="D62828"/>
-                </a:solidFill>
-                <a:latin typeface="Arial"/>
-              </a:rPr>
-              <a:t>beste</a:t>
-            </a:r>
-            <a:r>
-              <a:rPr sz="2200" b="1" i="0" dirty="0">
-                <a:solidFill>
-                  <a:srgbClr val="D62828"/>
-                </a:solidFill>
-                <a:latin typeface="Arial"/>
-              </a:rPr>
-              <a:t> </a:t>
-            </a:r>
-            <a:r>
-              <a:rPr sz="2200" b="1" i="0" dirty="0" err="1">
-                <a:solidFill>
-                  <a:srgbClr val="D62828"/>
-                </a:solidFill>
-                <a:latin typeface="Arial"/>
-              </a:rPr>
-              <a:t>Kompromiss</a:t>
-            </a:r>
-            <a:r>
-              <a:rPr sz="2200" b="1" i="0" dirty="0">
-                <a:solidFill>
-                  <a:srgbClr val="D62828"/>
-                </a:solidFill>
-                <a:latin typeface="Arial"/>
-              </a:rPr>
-              <a:t>?</a:t>
+              <a:t>Fenster ist der beste Kompromiss?</a:t>
             </a:r>
           </a:p>
         </p:txBody>
@@ -11940,7 +11575,7 @@
         <p:spPr>
           <a:xfrm>
             <a:off x="640080" y="502920"/>
-            <a:ext cx="10972800" cy="1005840"/>
+            <a:ext cx="10972800" cy="461665"/>
           </a:xfrm>
           <a:prstGeom prst="rect">
             <a:avLst/>
@@ -11962,6 +11597,190 @@
               </a:spcAft>
             </a:pPr>
             <a:r>
+              <a:rPr lang="de-DE" sz="3000" b="1" i="0" dirty="0">
+                <a:solidFill>
+                  <a:srgbClr val="1A2332"/>
+                </a:solidFill>
+                <a:latin typeface="Arial"/>
+              </a:rPr>
+              <a:t>Hauptkeulenunterschied</a:t>
+            </a:r>
+          </a:p>
+        </p:txBody>
+      </p:sp>
+      <p:sp>
+        <p:nvSpPr>
+          <p:cNvPr id="3" name="Rectangle 2"/>
+          <p:cNvSpPr/>
+          <p:nvPr/>
+        </p:nvSpPr>
+        <p:spPr>
+          <a:xfrm>
+            <a:off x="658368" y="1170432"/>
+            <a:ext cx="1005840" cy="82296"/>
+          </a:xfrm>
+          <a:prstGeom prst="rect">
+            <a:avLst/>
+          </a:prstGeom>
+          <a:solidFill>
+            <a:srgbClr val="D62828"/>
+          </a:solidFill>
+          <a:ln>
+            <a:noFill/>
+          </a:ln>
+          <a:effectLst/>
+        </p:spPr>
+        <p:style>
+          <a:lnRef idx="1">
+            <a:schemeClr val="accent1"/>
+          </a:lnRef>
+          <a:fillRef idx="3">
+            <a:schemeClr val="accent1"/>
+          </a:fillRef>
+          <a:effectRef idx="2">
+            <a:schemeClr val="accent1"/>
+          </a:effectRef>
+          <a:fontRef idx="minor">
+            <a:schemeClr val="lt1"/>
+          </a:fontRef>
+        </p:style>
+        <p:txBody>
+          <a:bodyPr rtlCol="0" anchor="ctr"/>
+          <a:lstStyle/>
+          <a:p>
+            <a:pPr algn="ctr"/>
+            <a:endParaRPr/>
+          </a:p>
+        </p:txBody>
+      </p:sp>
+      <p:pic>
+        <p:nvPicPr>
+          <p:cNvPr id="10" name="Grafik 9">
+            <a:extLst>
+              <a:ext uri="{FF2B5EF4-FFF2-40B4-BE49-F238E27FC236}">
+                <a16:creationId xmlns:a16="http://schemas.microsoft.com/office/drawing/2014/main" id="{6E0C536B-7D84-20F0-EF43-1251F42B5C60}"/>
+              </a:ext>
+            </a:extLst>
+          </p:cNvPr>
+          <p:cNvPicPr>
+            <a:picLocks noChangeAspect="1"/>
+          </p:cNvPicPr>
+          <p:nvPr/>
+        </p:nvPicPr>
+        <p:blipFill>
+          <a:blip r:embed="rId3"/>
+          <a:stretch>
+            <a:fillRect/>
+          </a:stretch>
+        </p:blipFill>
+        <p:spPr>
+          <a:xfrm>
+            <a:off x="183882" y="1519693"/>
+            <a:ext cx="5786250" cy="3818614"/>
+          </a:xfrm>
+          <a:prstGeom prst="rect">
+            <a:avLst/>
+          </a:prstGeom>
+        </p:spPr>
+      </p:pic>
+      <p:pic>
+        <p:nvPicPr>
+          <p:cNvPr id="11" name="Grafik 10">
+            <a:extLst>
+              <a:ext uri="{FF2B5EF4-FFF2-40B4-BE49-F238E27FC236}">
+                <a16:creationId xmlns:a16="http://schemas.microsoft.com/office/drawing/2014/main" id="{E6E73D98-395F-3ABB-E8E2-5172BDAA8348}"/>
+              </a:ext>
+            </a:extLst>
+          </p:cNvPr>
+          <p:cNvPicPr>
+            <a:picLocks noChangeAspect="1"/>
+          </p:cNvPicPr>
+          <p:nvPr/>
+        </p:nvPicPr>
+        <p:blipFill>
+          <a:blip r:embed="rId4"/>
+          <a:stretch>
+            <a:fillRect/>
+          </a:stretch>
+        </p:blipFill>
+        <p:spPr>
+          <a:xfrm>
+            <a:off x="6096000" y="1540004"/>
+            <a:ext cx="5817360" cy="3798303"/>
+          </a:xfrm>
+          <a:prstGeom prst="rect">
+            <a:avLst/>
+          </a:prstGeom>
+        </p:spPr>
+      </p:pic>
+    </p:spTree>
+  </p:cSld>
+  <p:clrMapOvr>
+    <a:masterClrMapping/>
+  </p:clrMapOvr>
+</p:sld>
+</file>
+
+<file path=ppt/slides/slide7.xml><?xml version="1.0" encoding="utf-8"?>
+<p:sld xmlns:a="http://schemas.openxmlformats.org/drawingml/2006/main" xmlns:r="http://schemas.openxmlformats.org/officeDocument/2006/relationships" xmlns:p="http://schemas.openxmlformats.org/presentationml/2006/main">
+  <p:cSld>
+    <p:spTree>
+      <p:nvGrpSpPr>
+        <p:cNvPr id="1" name="">
+          <a:extLst>
+            <a:ext uri="{FF2B5EF4-FFF2-40B4-BE49-F238E27FC236}">
+              <a16:creationId xmlns:a16="http://schemas.microsoft.com/office/drawing/2014/main" id="{5CDA9D6E-FEB5-CB3A-070E-D4BFE12A6843}"/>
+            </a:ext>
+          </a:extLst>
+        </p:cNvPr>
+        <p:cNvGrpSpPr/>
+        <p:nvPr/>
+      </p:nvGrpSpPr>
+      <p:grpSpPr>
+        <a:xfrm>
+          <a:off x="0" y="0"/>
+          <a:ext cx="0" cy="0"/>
+          <a:chOff x="0" y="0"/>
+          <a:chExt cx="0" cy="0"/>
+        </a:xfrm>
+      </p:grpSpPr>
+      <p:sp>
+        <p:nvSpPr>
+          <p:cNvPr id="2" name="TextBox 1">
+            <a:extLst>
+              <a:ext uri="{FF2B5EF4-FFF2-40B4-BE49-F238E27FC236}">
+                <a16:creationId xmlns:a16="http://schemas.microsoft.com/office/drawing/2014/main" id="{D4B861B2-4F57-5458-8D03-C75FAC7CDA4B}"/>
+              </a:ext>
+            </a:extLst>
+          </p:cNvPr>
+          <p:cNvSpPr txBox="1"/>
+          <p:nvPr/>
+        </p:nvSpPr>
+        <p:spPr>
+          <a:xfrm>
+            <a:off x="640080" y="502920"/>
+            <a:ext cx="10972800" cy="1005840"/>
+          </a:xfrm>
+          <a:prstGeom prst="rect">
+            <a:avLst/>
+          </a:prstGeom>
+          <a:noFill/>
+        </p:spPr>
+        <p:txBody>
+          <a:bodyPr wrap="square" lIns="0" tIns="0" rIns="0" bIns="0" anchor="t">
+            <a:spAutoFit/>
+          </a:bodyPr>
+          <a:lstStyle/>
+          <a:p>
+            <a:pPr algn="l">
+              <a:spcBef>
+                <a:spcPts val="0"/>
+              </a:spcBef>
+              <a:spcAft>
+                <a:spcPts val="0"/>
+              </a:spcAft>
+            </a:pPr>
+            <a:r>
               <a:rPr sz="3000" b="1" i="0">
                 <a:solidFill>
                   <a:srgbClr val="1A2332"/>
@@ -11975,7 +11794,13 @@
       </p:sp>
       <p:sp>
         <p:nvSpPr>
-          <p:cNvPr id="3" name="Rectangle 2"/>
+          <p:cNvPr id="3" name="Rectangle 2">
+            <a:extLst>
+              <a:ext uri="{FF2B5EF4-FFF2-40B4-BE49-F238E27FC236}">
+                <a16:creationId xmlns:a16="http://schemas.microsoft.com/office/drawing/2014/main" id="{F3677843-D818-0C08-8187-0F44FDB6F53F}"/>
+              </a:ext>
+            </a:extLst>
+          </p:cNvPr>
           <p:cNvSpPr/>
           <p:nvPr/>
         </p:nvSpPr>
@@ -12020,7 +11845,13 @@
       </p:sp>
       <p:sp>
         <p:nvSpPr>
-          <p:cNvPr id="4" name="TextBox 3"/>
+          <p:cNvPr id="4" name="TextBox 3">
+            <a:extLst>
+              <a:ext uri="{FF2B5EF4-FFF2-40B4-BE49-F238E27FC236}">
+                <a16:creationId xmlns:a16="http://schemas.microsoft.com/office/drawing/2014/main" id="{6602EF99-55B3-59DB-565F-B4125AEE5009}"/>
+              </a:ext>
+            </a:extLst>
+          </p:cNvPr>
           <p:cNvSpPr txBox="1"/>
           <p:nvPr/>
         </p:nvSpPr>
@@ -12113,7 +11944,13 @@
       </p:sp>
       <p:sp>
         <p:nvSpPr>
-          <p:cNvPr id="5" name="Rounded Rectangle 4"/>
+          <p:cNvPr id="5" name="Rounded Rectangle 4">
+            <a:extLst>
+              <a:ext uri="{FF2B5EF4-FFF2-40B4-BE49-F238E27FC236}">
+                <a16:creationId xmlns:a16="http://schemas.microsoft.com/office/drawing/2014/main" id="{5162A21D-96A6-6823-B517-58B16260A024}"/>
+              </a:ext>
+            </a:extLst>
+          </p:cNvPr>
           <p:cNvSpPr/>
           <p:nvPr/>
         </p:nvSpPr>
@@ -12177,7 +12014,13 @@
       </p:sp>
       <p:sp>
         <p:nvSpPr>
-          <p:cNvPr id="6" name="Right Arrow 5"/>
+          <p:cNvPr id="6" name="Right Arrow 5">
+            <a:extLst>
+              <a:ext uri="{FF2B5EF4-FFF2-40B4-BE49-F238E27FC236}">
+                <a16:creationId xmlns:a16="http://schemas.microsoft.com/office/drawing/2014/main" id="{3D702AC9-1D8D-575F-B877-356B6494A077}"/>
+              </a:ext>
+            </a:extLst>
+          </p:cNvPr>
           <p:cNvSpPr/>
           <p:nvPr/>
         </p:nvSpPr>
@@ -12222,7 +12065,13 @@
       </p:sp>
       <p:sp>
         <p:nvSpPr>
-          <p:cNvPr id="7" name="Rounded Rectangle 6"/>
+          <p:cNvPr id="7" name="Rounded Rectangle 6">
+            <a:extLst>
+              <a:ext uri="{FF2B5EF4-FFF2-40B4-BE49-F238E27FC236}">
+                <a16:creationId xmlns:a16="http://schemas.microsoft.com/office/drawing/2014/main" id="{5D7C3F74-87A9-E60C-FAC1-142011FCC5CF}"/>
+              </a:ext>
+            </a:extLst>
+          </p:cNvPr>
           <p:cNvSpPr/>
           <p:nvPr/>
         </p:nvSpPr>
@@ -12286,7 +12135,13 @@
       </p:sp>
       <p:sp>
         <p:nvSpPr>
-          <p:cNvPr id="8" name="TextBox 7"/>
+          <p:cNvPr id="8" name="TextBox 7">
+            <a:extLst>
+              <a:ext uri="{FF2B5EF4-FFF2-40B4-BE49-F238E27FC236}">
+                <a16:creationId xmlns:a16="http://schemas.microsoft.com/office/drawing/2014/main" id="{2081E758-18C8-2AB2-23FC-29E21BD650FA}"/>
+              </a:ext>
+            </a:extLst>
+          </p:cNvPr>
           <p:cNvSpPr txBox="1"/>
           <p:nvPr/>
         </p:nvSpPr>
@@ -12329,7 +12184,13 @@
       </p:sp>
       <p:sp>
         <p:nvSpPr>
-          <p:cNvPr id="9" name="TextBox 8"/>
+          <p:cNvPr id="9" name="TextBox 8">
+            <a:extLst>
+              <a:ext uri="{FF2B5EF4-FFF2-40B4-BE49-F238E27FC236}">
+                <a16:creationId xmlns:a16="http://schemas.microsoft.com/office/drawing/2014/main" id="{80375380-78D7-C9E5-E9DC-A269253F8E68}"/>
+              </a:ext>
+            </a:extLst>
+          </p:cNvPr>
           <p:cNvSpPr txBox="1"/>
           <p:nvPr/>
         </p:nvSpPr>
@@ -12370,6 +12231,11 @@
         </p:txBody>
       </p:sp>
     </p:spTree>
+    <p:extLst>
+      <p:ext uri="{BB962C8B-B14F-4D97-AF65-F5344CB8AC3E}">
+        <p14:creationId xmlns:p14="http://schemas.microsoft.com/office/powerpoint/2010/main" val="3477102263"/>
+      </p:ext>
+    </p:extLst>
   </p:cSld>
   <p:clrMapOvr>
     <a:masterClrMapping/>
@@ -12377,7 +12243,7 @@
 </p:sld>
 </file>
 
-<file path=ppt/slides/slide7.xml><?xml version="1.0" encoding="utf-8"?>
+<file path=ppt/slides/slide8.xml><?xml version="1.0" encoding="utf-8"?>
 <p:sld xmlns:a="http://schemas.openxmlformats.org/drawingml/2006/main" xmlns:r="http://schemas.openxmlformats.org/officeDocument/2006/relationships" xmlns:p="http://schemas.openxmlformats.org/presentationml/2006/main">
   <p:cSld>
     <p:bg>
@@ -13101,7 +12967,7 @@
 </p:sld>
 </file>
 
-<file path=ppt/slides/slide8.xml><?xml version="1.0" encoding="utf-8"?>
+<file path=ppt/slides/slide9.xml><?xml version="1.0" encoding="utf-8"?>
 <p:sld xmlns:a="http://schemas.openxmlformats.org/drawingml/2006/main" xmlns:r="http://schemas.openxmlformats.org/officeDocument/2006/relationships" xmlns:p="http://schemas.openxmlformats.org/presentationml/2006/main">
   <p:cSld>
     <p:bg>

</xml_diff>

<commit_message>
Update documentation and enhance HRV analysis script: add explanations for window stability and computational effort; remove unused presentation text file; update presentation and figures.
</commit_message>
<xml_diff>
--- a/HRV_Praesentation_korrigiert.pptx
+++ b/HRV_Praesentation_korrigiert.pptx
@@ -5,18 +5,16 @@
     <p:sldMasterId id="2147483648" r:id="rId1"/>
   </p:sldMasterIdLst>
   <p:notesMasterIdLst>
-    <p:notesMasterId r:id="rId11"/>
+    <p:notesMasterId r:id="rId9"/>
   </p:notesMasterIdLst>
   <p:sldIdLst>
     <p:sldId id="256" r:id="rId2"/>
     <p:sldId id="257" r:id="rId3"/>
-    <p:sldId id="258" r:id="rId4"/>
-    <p:sldId id="259" r:id="rId5"/>
-    <p:sldId id="260" r:id="rId6"/>
-    <p:sldId id="261" r:id="rId7"/>
-    <p:sldId id="264" r:id="rId8"/>
-    <p:sldId id="262" r:id="rId9"/>
-    <p:sldId id="263" r:id="rId10"/>
+    <p:sldId id="260" r:id="rId4"/>
+    <p:sldId id="261" r:id="rId5"/>
+    <p:sldId id="264" r:id="rId6"/>
+    <p:sldId id="262" r:id="rId7"/>
+    <p:sldId id="263" r:id="rId8"/>
   </p:sldIdLst>
   <p:sldSz cx="12192000" cy="6858000"/>
   <p:notesSz cx="6858000" cy="9144000"/>
@@ -304,220 +302,17 @@
           <a:lstStyle/>
           <a:p>
             <a:r>
-              <a:rPr dirty="0"/>
-              <a:t>GESAMT-ZIEL: 8 </a:t>
-            </a:r>
-            <a:r>
-              <a:rPr dirty="0" err="1"/>
-              <a:t>Minuten</a:t>
-            </a:r>
-            <a:r>
-              <a:rPr dirty="0"/>
-              <a:t>, </a:t>
-            </a:r>
-            <a:r>
-              <a:rPr dirty="0" err="1"/>
-              <a:t>sehr</a:t>
-            </a:r>
-            <a:r>
-              <a:rPr dirty="0"/>
-              <a:t> </a:t>
-            </a:r>
-            <a:r>
-              <a:rPr dirty="0" err="1"/>
-              <a:t>wenige</a:t>
-            </a:r>
-            <a:r>
-              <a:rPr dirty="0"/>
-              <a:t> </a:t>
-            </a:r>
-            <a:r>
-              <a:rPr dirty="0" err="1"/>
-              <a:t>Folien</a:t>
-            </a:r>
-            <a:r>
-              <a:rPr dirty="0"/>
-              <a:t> – der </a:t>
-            </a:r>
-            <a:r>
-              <a:rPr dirty="0" err="1"/>
-              <a:t>Fokus</a:t>
-            </a:r>
-            <a:r>
-              <a:rPr dirty="0"/>
-              <a:t> </a:t>
-            </a:r>
-            <a:r>
-              <a:rPr dirty="0" err="1"/>
-              <a:t>liegt</a:t>
-            </a:r>
-            <a:r>
-              <a:rPr dirty="0"/>
-              <a:t> auf der LIVE-Demo von Code und Plots.</a:t>
-            </a:r>
-          </a:p>
-          <a:p>
-            <a:endParaRPr dirty="0"/>
-          </a:p>
-          <a:p>
-            <a:r>
-              <a:rPr dirty="0"/>
-              <a:t>(ca. 0:00–0:30) </a:t>
-            </a:r>
-            <a:r>
-              <a:rPr dirty="0" err="1"/>
-              <a:t>Begrüßung</a:t>
-            </a:r>
-            <a:r>
-              <a:rPr dirty="0"/>
-              <a:t>. „In </a:t>
-            </a:r>
-            <a:r>
-              <a:rPr dirty="0" err="1"/>
-              <a:t>unserem</a:t>
-            </a:r>
-            <a:r>
-              <a:rPr dirty="0"/>
-              <a:t> Projekt </a:t>
-            </a:r>
-            <a:r>
-              <a:rPr dirty="0" err="1"/>
-              <a:t>untersuchen</a:t>
-            </a:r>
-            <a:r>
-              <a:rPr dirty="0"/>
-              <a:t> </a:t>
-            </a:r>
-            <a:r>
-              <a:rPr dirty="0" err="1"/>
-              <a:t>wir</a:t>
-            </a:r>
-            <a:r>
-              <a:rPr dirty="0"/>
-              <a:t>, </a:t>
-            </a:r>
-            <a:r>
-              <a:rPr dirty="0" err="1"/>
-              <a:t>wie</a:t>
-            </a:r>
-            <a:r>
-              <a:rPr dirty="0"/>
-              <a:t> </a:t>
-            </a:r>
-            <a:r>
-              <a:rPr dirty="0" err="1"/>
-              <a:t>sich</a:t>
-            </a:r>
-            <a:r>
-              <a:rPr dirty="0"/>
-              <a:t> </a:t>
-            </a:r>
-            <a:r>
-              <a:rPr dirty="0" err="1"/>
-              <a:t>verschiedene</a:t>
-            </a:r>
-            <a:r>
-              <a:rPr dirty="0"/>
-              <a:t> FFT-</a:t>
-            </a:r>
-            <a:r>
-              <a:rPr dirty="0" err="1"/>
-              <a:t>Fensterfunktionen</a:t>
-            </a:r>
-            <a:r>
-              <a:rPr dirty="0"/>
-              <a:t> auf die </a:t>
-            </a:r>
-            <a:r>
-              <a:rPr dirty="0" err="1"/>
-              <a:t>Analyse</a:t>
-            </a:r>
-            <a:r>
-              <a:rPr dirty="0"/>
-              <a:t> der </a:t>
-            </a:r>
-            <a:r>
-              <a:rPr dirty="0" err="1"/>
-              <a:t>Herzfrequenzvariabilität</a:t>
-            </a:r>
-            <a:r>
-              <a:rPr dirty="0"/>
-              <a:t> </a:t>
-            </a:r>
-            <a:r>
-              <a:rPr dirty="0" err="1"/>
-              <a:t>auswirken</a:t>
-            </a:r>
-            <a:r>
-              <a:rPr dirty="0"/>
-              <a:t>. Wir </a:t>
-            </a:r>
-            <a:r>
-              <a:rPr dirty="0" err="1"/>
-              <a:t>zeigen</a:t>
-            </a:r>
-            <a:r>
-              <a:rPr dirty="0"/>
-              <a:t> den Code und die </a:t>
-            </a:r>
-            <a:r>
-              <a:rPr dirty="0" err="1"/>
-              <a:t>Ergebnisse</a:t>
-            </a:r>
-            <a:r>
-              <a:rPr dirty="0"/>
-              <a:t> </a:t>
-            </a:r>
-            <a:r>
-              <a:rPr dirty="0" err="1"/>
-              <a:t>gleich</a:t>
-            </a:r>
-            <a:r>
-              <a:rPr dirty="0"/>
-              <a:t> live – die </a:t>
-            </a:r>
-            <a:r>
-              <a:rPr dirty="0" err="1"/>
-              <a:t>Folien</a:t>
-            </a:r>
-            <a:r>
-              <a:rPr dirty="0"/>
-              <a:t> </a:t>
-            </a:r>
-            <a:r>
-              <a:rPr dirty="0" err="1"/>
-              <a:t>halten</a:t>
-            </a:r>
-            <a:r>
-              <a:rPr dirty="0"/>
-              <a:t> </a:t>
-            </a:r>
-            <a:r>
-              <a:rPr dirty="0" err="1"/>
-              <a:t>wir</a:t>
-            </a:r>
-            <a:r>
-              <a:rPr dirty="0"/>
-              <a:t> </a:t>
-            </a:r>
-            <a:r>
-              <a:rPr dirty="0" err="1"/>
-              <a:t>bewusst</a:t>
-            </a:r>
-            <a:r>
-              <a:rPr dirty="0"/>
-              <a:t> </a:t>
-            </a:r>
-            <a:r>
-              <a:rPr dirty="0" err="1"/>
-              <a:t>kurz</a:t>
-            </a:r>
-            <a:r>
-              <a:rPr dirty="0"/>
-              <a:t>.“</a:t>
-            </a:r>
-          </a:p>
-          <a:p>
+              <a:rPr lang="de-DE" sz="1200" kern="1200" dirty="0">
+                <a:solidFill>
+                  <a:schemeClr val="tx1"/>
+                </a:solidFill>
+                <a:effectLst/>
+                <a:latin typeface="+mn-lt"/>
+                <a:ea typeface="+mn-ea"/>
+                <a:cs typeface="+mn-cs"/>
+              </a:rPr>
+              <a:t>Unser Thema war der „Einfluss unterschiedlicher FFT-Fensterfunktionen auf die Herzfrequenzvariabilität-Analyse“. Und wie genau die Wahl der der Fensterfunktion die Kennwerte der Herzfrequenzvariabilität verändern kann.</a:t>
+            </a:r>
             <a:endParaRPr dirty="0"/>
           </a:p>
         </p:txBody>
@@ -587,268 +382,94 @@
           <a:lstStyle/>
           <a:p>
             <a:r>
-              <a:rPr dirty="0"/>
-              <a:t>(ca. 0:30–1:45) Motivation in </a:t>
-            </a:r>
-            <a:r>
-              <a:rPr dirty="0" err="1"/>
-              <a:t>einem</a:t>
-            </a:r>
-            <a:r>
-              <a:rPr dirty="0"/>
-              <a:t> Satz pro </a:t>
-            </a:r>
-            <a:r>
-              <a:rPr dirty="0" err="1"/>
-              <a:t>Punkt</a:t>
-            </a:r>
-            <a:r>
-              <a:rPr dirty="0"/>
-              <a:t> – nicht </a:t>
-            </a:r>
-            <a:r>
-              <a:rPr dirty="0" err="1"/>
-              <a:t>vorlesen</a:t>
-            </a:r>
-            <a:r>
-              <a:rPr dirty="0"/>
-              <a:t>, </a:t>
-            </a:r>
-            <a:r>
-              <a:rPr dirty="0" err="1"/>
-              <a:t>frei</a:t>
-            </a:r>
-            <a:r>
-              <a:rPr dirty="0"/>
+              <a:rPr lang="de-DE" sz="1200" kern="1200" dirty="0">
+                <a:solidFill>
+                  <a:schemeClr val="tx1"/>
+                </a:solidFill>
+                <a:effectLst/>
+                <a:latin typeface="+mn-lt"/>
+                <a:ea typeface="+mn-ea"/>
+                <a:cs typeface="+mn-cs"/>
+              </a:rPr>
+              <a:t>Also das Herz von einem Mensch schlägt nie genau gleich, diese Schwankung ist aber Gesund und man nennt sie Herzfrequenzvariabilität.  Um diese Rhythmen sichtbar zu machen, zerlegen wir das Signal mithilfe der Fast-Fourier-Transformation in seine Frequenzen. Dabei ist das Problem, dass wir immer nur einen endlichen Ausschnitt betrachten, dass erzeugt dann beim zusammensetzen an den Rändern, sogenannte </a:t>
+            </a:r>
+            <a:r>
+              <a:rPr lang="de-DE" sz="1200" kern="1200" dirty="0" err="1">
+                <a:solidFill>
+                  <a:schemeClr val="tx1"/>
+                </a:solidFill>
+                <a:effectLst/>
+                <a:latin typeface="+mn-lt"/>
+                <a:ea typeface="+mn-ea"/>
+                <a:cs typeface="+mn-cs"/>
+              </a:rPr>
+              <a:t>Spectral</a:t>
+            </a:r>
+            <a:r>
+              <a:rPr lang="de-DE" sz="1200" kern="1200" dirty="0">
+                <a:solidFill>
+                  <a:schemeClr val="tx1"/>
+                </a:solidFill>
+                <a:effectLst/>
+                <a:latin typeface="+mn-lt"/>
+                <a:ea typeface="+mn-ea"/>
+                <a:cs typeface="+mn-cs"/>
+              </a:rPr>
+              <a:t> Leakage, welche die Werte verfälscht. </a:t>
+            </a:r>
+            <a:br>
+              <a:rPr lang="de-DE" sz="1200" kern="1200" dirty="0">
+                <a:solidFill>
+                  <a:schemeClr val="tx1"/>
+                </a:solidFill>
+                <a:effectLst/>
+                <a:latin typeface="+mn-lt"/>
+                <a:ea typeface="+mn-ea"/>
+                <a:cs typeface="+mn-cs"/>
+              </a:rPr>
+            </a:br>
+            <a:r>
+              <a:rPr lang="de-DE" sz="1200" kern="1200" dirty="0">
+                <a:solidFill>
+                  <a:schemeClr val="tx1"/>
+                </a:solidFill>
+                <a:effectLst/>
+                <a:latin typeface="+mn-lt"/>
+                <a:ea typeface="+mn-ea"/>
+                <a:cs typeface="+mn-cs"/>
+              </a:rPr>
+              <a:t>Dafür gibt es jetzt Fensterfunktionen, die diesen Leck-Effekt dämpfen können, dafür jedoch die Hauptkeule verbeitern und damit ihre Frequenzauflösung verschlechtern. </a:t>
+            </a:r>
+            <a:br>
+              <a:rPr lang="de-DE" sz="1200" kern="1200" dirty="0">
+                <a:solidFill>
+                  <a:schemeClr val="tx1"/>
+                </a:solidFill>
+                <a:effectLst/>
+                <a:latin typeface="+mn-lt"/>
+                <a:ea typeface="+mn-ea"/>
+                <a:cs typeface="+mn-cs"/>
+              </a:rPr>
+            </a:br>
+            <a:r>
+              <a:rPr lang="de-DE" sz="1200" kern="1200" dirty="0">
+                <a:solidFill>
+                  <a:schemeClr val="tx1"/>
+                </a:solidFill>
+                <a:effectLst/>
+                <a:latin typeface="+mn-lt"/>
+                <a:ea typeface="+mn-ea"/>
+                <a:cs typeface="+mn-cs"/>
+              </a:rPr>
+              <a:t>Unsere Leitfrage, war nun also. Welches Fenster ist der beste Kompromiss?</a:t>
+            </a:r>
+            <a:r>
+              <a:rPr lang="de-DE" dirty="0">
+                <a:effectLst/>
+              </a:rPr>
               <a:t> </a:t>
             </a:r>
-            <a:r>
-              <a:rPr dirty="0" err="1"/>
-              <a:t>erzählen</a:t>
-            </a:r>
-            <a:r>
-              <a:rPr dirty="0"/>
-              <a:t>.</a:t>
-            </a:r>
-          </a:p>
-          <a:p>
             <a:endParaRPr dirty="0"/>
-          </a:p>
-          <a:p>
-            <a:r>
-              <a:rPr dirty="0"/>
-              <a:t>• HRV = </a:t>
-            </a:r>
-            <a:r>
-              <a:rPr dirty="0" err="1"/>
-              <a:t>Herzfrequenzvariabilität</a:t>
-            </a:r>
-            <a:r>
-              <a:rPr dirty="0"/>
-              <a:t>; die </a:t>
-            </a:r>
-            <a:r>
-              <a:rPr dirty="0" err="1"/>
-              <a:t>Schwankung</a:t>
-            </a:r>
-            <a:r>
-              <a:rPr dirty="0"/>
-              <a:t> </a:t>
-            </a:r>
-            <a:r>
-              <a:rPr dirty="0" err="1"/>
-              <a:t>ist</a:t>
-            </a:r>
-            <a:r>
-              <a:rPr dirty="0"/>
-              <a:t> </a:t>
-            </a:r>
-            <a:r>
-              <a:rPr dirty="0" err="1"/>
-              <a:t>gesund</a:t>
-            </a:r>
-            <a:r>
-              <a:rPr dirty="0"/>
-              <a:t> und </a:t>
-            </a:r>
-            <a:r>
-              <a:rPr dirty="0" err="1"/>
-              <a:t>verrät</a:t>
-            </a:r>
-            <a:r>
-              <a:rPr dirty="0"/>
-              <a:t> </a:t>
-            </a:r>
-            <a:r>
-              <a:rPr dirty="0" err="1"/>
-              <a:t>etwas</a:t>
-            </a:r>
-            <a:r>
-              <a:rPr dirty="0"/>
-              <a:t> </a:t>
-            </a:r>
-            <a:r>
-              <a:rPr dirty="0" err="1"/>
-              <a:t>über</a:t>
-            </a:r>
-            <a:r>
-              <a:rPr dirty="0"/>
-              <a:t> das vegetative </a:t>
-            </a:r>
-            <a:r>
-              <a:rPr dirty="0" err="1"/>
-              <a:t>Nervensystem</a:t>
-            </a:r>
-            <a:r>
-              <a:rPr dirty="0"/>
-              <a:t>.</a:t>
-            </a:r>
-          </a:p>
-          <a:p>
-            <a:r>
-              <a:rPr dirty="0"/>
-              <a:t>• FFT = </a:t>
-            </a:r>
-            <a:r>
-              <a:rPr dirty="0" err="1"/>
-              <a:t>zerlegt</a:t>
-            </a:r>
-            <a:r>
-              <a:rPr dirty="0"/>
-              <a:t> das Signal in </a:t>
-            </a:r>
-            <a:r>
-              <a:rPr dirty="0" err="1"/>
-              <a:t>Frequenzen</a:t>
-            </a:r>
-            <a:r>
-              <a:rPr dirty="0"/>
-              <a:t> (</a:t>
-            </a:r>
-            <a:r>
-              <a:rPr dirty="0" err="1"/>
-              <a:t>kurz</a:t>
-            </a:r>
-            <a:r>
-              <a:rPr dirty="0"/>
-              <a:t>: </a:t>
-            </a:r>
-            <a:r>
-              <a:rPr dirty="0" err="1"/>
-              <a:t>wie</a:t>
-            </a:r>
-            <a:r>
-              <a:rPr dirty="0"/>
-              <a:t> </a:t>
-            </a:r>
-            <a:r>
-              <a:rPr dirty="0" err="1"/>
-              <a:t>ein</a:t>
-            </a:r>
-            <a:r>
-              <a:rPr dirty="0"/>
-              <a:t> Prisma / </a:t>
-            </a:r>
-            <a:r>
-              <a:rPr dirty="0" err="1"/>
-              <a:t>Akkord</a:t>
-            </a:r>
-            <a:r>
-              <a:rPr dirty="0"/>
-              <a:t> in </a:t>
-            </a:r>
-            <a:r>
-              <a:rPr dirty="0" err="1"/>
-              <a:t>Einzeltöne</a:t>
-            </a:r>
-            <a:r>
-              <a:rPr dirty="0"/>
-              <a:t>).</a:t>
-            </a:r>
-          </a:p>
-          <a:p>
-            <a:r>
-              <a:rPr dirty="0"/>
-              <a:t>• Leakage </a:t>
-            </a:r>
-            <a:r>
-              <a:rPr dirty="0" err="1"/>
-              <a:t>kurz</a:t>
-            </a:r>
-            <a:r>
-              <a:rPr dirty="0"/>
-              <a:t> </a:t>
-            </a:r>
-            <a:r>
-              <a:rPr dirty="0" err="1"/>
-              <a:t>anteasern</a:t>
-            </a:r>
-            <a:r>
-              <a:rPr dirty="0"/>
-              <a:t> – Details </a:t>
-            </a:r>
-            <a:r>
-              <a:rPr dirty="0" err="1"/>
-              <a:t>zeigen</a:t>
-            </a:r>
-            <a:r>
-              <a:rPr dirty="0"/>
-              <a:t> </a:t>
-            </a:r>
-            <a:r>
-              <a:rPr dirty="0" err="1"/>
-              <a:t>wir</a:t>
-            </a:r>
-            <a:r>
-              <a:rPr dirty="0"/>
-              <a:t> </a:t>
-            </a:r>
-            <a:r>
-              <a:rPr dirty="0" err="1"/>
-              <a:t>gleich</a:t>
-            </a:r>
-            <a:r>
-              <a:rPr dirty="0"/>
-              <a:t> live </a:t>
-            </a:r>
-            <a:r>
-              <a:rPr dirty="0" err="1"/>
-              <a:t>im</a:t>
-            </a:r>
-            <a:r>
-              <a:rPr dirty="0"/>
-              <a:t> Spektrum.</a:t>
-            </a:r>
-          </a:p>
-          <a:p>
-            <a:r>
-              <a:rPr dirty="0"/>
-              <a:t>• Die </a:t>
-            </a:r>
-            <a:r>
-              <a:rPr dirty="0" err="1"/>
-              <a:t>Leitfrage</a:t>
-            </a:r>
-            <a:r>
-              <a:rPr dirty="0"/>
-              <a:t> </a:t>
-            </a:r>
-            <a:r>
-              <a:rPr dirty="0" err="1"/>
-              <a:t>ist</a:t>
-            </a:r>
-            <a:r>
-              <a:rPr dirty="0"/>
-              <a:t> der rote Faden der </a:t>
-            </a:r>
-            <a:r>
-              <a:rPr dirty="0" err="1"/>
-              <a:t>Präsentation</a:t>
-            </a:r>
-            <a:r>
-              <a:rPr dirty="0"/>
-              <a:t>.</a:t>
-            </a:r>
           </a:p>
         </p:txBody>
       </p:sp>
@@ -917,28 +538,16 @@
           <a:lstStyle/>
           <a:p>
             <a:r>
-              <a:t>(ca. 1:45–3:15) DIE zentrale Erklärfolie – hier ruhig etwas mehr Zeit.</a:t>
-            </a:r>
-          </a:p>
-          <a:p>
-            <a:endParaRPr/>
-          </a:p>
-          <a:p>
-            <a:r>
-              <a:t>Kette einmal durchgehen: EKG rein → filtern → R-Zacken finden → Abstände (RR) berechnen → gleichmäßig abtasten (FFT braucht gleiche Abstände) → FFT mit jedem Fenster → Leistung in den Bändern VLF/LF/HF + Wasserfall.</a:t>
-            </a:r>
-          </a:p>
-          <a:p>
-            <a:endParaRPr/>
-          </a:p>
-          <a:p>
-            <a:r>
-              <a:t>Betonen: Der rote Block (FFT × 6 Fenster) ist das eigentliche Experiment – alles davor ist gleich, nur das Fenster wird variiert.</a:t>
-            </a:r>
-          </a:p>
-          <a:p>
-            <a:r>
-              <a:t>Überleitung: „Was eine Fensterfunktion überhaupt ist, dazu ein Bild.“</a:t>
+              <a:rPr lang="de-DE" sz="1200" kern="1200" dirty="0">
+                <a:solidFill>
+                  <a:schemeClr val="tx1"/>
+                </a:solidFill>
+                <a:effectLst/>
+                <a:latin typeface="+mn-lt"/>
+                <a:ea typeface="+mn-ea"/>
+                <a:cs typeface="+mn-cs"/>
+              </a:rPr>
+              <a:t>Und jetzt würde ich dann auch schon in den Programmcode wechseln um weiterzumachen.</a:t>
             </a:r>
           </a:p>
         </p:txBody>
@@ -1008,384 +617,30 @@
           <a:lstStyle/>
           <a:p>
             <a:r>
-              <a:rPr dirty="0"/>
-              <a:t>(ca. 3:15–4:15) Nur das </a:t>
-            </a:r>
-            <a:r>
-              <a:rPr dirty="0" err="1"/>
-              <a:t>Prinzip</a:t>
-            </a:r>
-            <a:r>
-              <a:rPr dirty="0"/>
-              <a:t> – die </a:t>
-            </a:r>
-            <a:r>
-              <a:rPr dirty="0" err="1"/>
-              <a:t>echten</a:t>
-            </a:r>
-            <a:r>
-              <a:rPr dirty="0"/>
-              <a:t> </a:t>
-            </a:r>
-            <a:r>
-              <a:rPr dirty="0" err="1"/>
-              <a:t>Kurven</a:t>
-            </a:r>
-            <a:r>
-              <a:rPr dirty="0"/>
-              <a:t> </a:t>
-            </a:r>
-            <a:r>
-              <a:rPr dirty="0" err="1"/>
-              <a:t>zeigen</a:t>
-            </a:r>
-            <a:r>
-              <a:rPr dirty="0"/>
-              <a:t> </a:t>
-            </a:r>
-            <a:r>
-              <a:rPr dirty="0" err="1"/>
-              <a:t>wir</a:t>
-            </a:r>
-            <a:r>
-              <a:rPr dirty="0"/>
-              <a:t> </a:t>
-            </a:r>
-            <a:r>
-              <a:rPr dirty="0" err="1"/>
-              <a:t>gleich</a:t>
-            </a:r>
-            <a:r>
-              <a:rPr dirty="0"/>
-              <a:t> live (Fenster </a:t>
-            </a:r>
-            <a:r>
-              <a:rPr dirty="0" err="1"/>
-              <a:t>im</a:t>
-            </a:r>
-            <a:r>
-              <a:rPr dirty="0"/>
-              <a:t> Zeit-/</a:t>
-            </a:r>
-            <a:r>
-              <a:rPr dirty="0" err="1"/>
-              <a:t>Frequenzbereich</a:t>
-            </a:r>
-            <a:r>
-              <a:rPr dirty="0"/>
-              <a:t>).</a:t>
-            </a:r>
-          </a:p>
-          <a:p>
-            <a:endParaRPr dirty="0"/>
-          </a:p>
-          <a:p>
-            <a:r>
-              <a:rPr dirty="0"/>
-              <a:t>• </a:t>
-            </a:r>
-            <a:r>
-              <a:rPr dirty="0" err="1"/>
-              <a:t>Hauptkeule</a:t>
-            </a:r>
-            <a:r>
-              <a:rPr dirty="0"/>
-              <a:t> = der „</a:t>
-            </a:r>
-            <a:r>
-              <a:rPr dirty="0" err="1"/>
-              <a:t>echte</a:t>
-            </a:r>
-            <a:r>
-              <a:rPr dirty="0"/>
-              <a:t>“ Peak; </a:t>
-            </a:r>
-            <a:r>
-              <a:rPr dirty="0" err="1"/>
-              <a:t>schmal</a:t>
-            </a:r>
-            <a:r>
-              <a:rPr dirty="0"/>
-              <a:t> = </a:t>
-            </a:r>
-            <a:r>
-              <a:rPr dirty="0" err="1"/>
-              <a:t>zwei</a:t>
-            </a:r>
-            <a:r>
-              <a:rPr dirty="0"/>
-              <a:t> </a:t>
-            </a:r>
-            <a:r>
-              <a:rPr dirty="0" err="1"/>
-              <a:t>nahe</a:t>
-            </a:r>
-            <a:r>
-              <a:rPr dirty="0"/>
-              <a:t> </a:t>
-            </a:r>
-            <a:r>
-              <a:rPr dirty="0" err="1"/>
-              <a:t>Frequenzen</a:t>
-            </a:r>
-            <a:r>
-              <a:rPr dirty="0"/>
-              <a:t> </a:t>
-            </a:r>
-            <a:r>
-              <a:rPr dirty="0" err="1"/>
-              <a:t>bleiben</a:t>
-            </a:r>
-            <a:r>
-              <a:rPr dirty="0"/>
-              <a:t> </a:t>
-            </a:r>
-            <a:r>
-              <a:rPr dirty="0" err="1"/>
-              <a:t>trennbar</a:t>
-            </a:r>
-            <a:r>
-              <a:rPr dirty="0"/>
-              <a:t>.</a:t>
-            </a:r>
-          </a:p>
-          <a:p>
-            <a:r>
-              <a:rPr dirty="0"/>
-              <a:t>• </a:t>
-            </a:r>
-            <a:r>
-              <a:rPr dirty="0" err="1"/>
-              <a:t>Nebenkeulen</a:t>
-            </a:r>
-            <a:r>
-              <a:rPr dirty="0"/>
-              <a:t> = </a:t>
-            </a:r>
-            <a:r>
-              <a:rPr dirty="0" err="1"/>
-              <a:t>unerwünschtes</a:t>
-            </a:r>
-            <a:r>
-              <a:rPr dirty="0"/>
-              <a:t> </a:t>
-            </a:r>
-            <a:r>
-              <a:rPr dirty="0" err="1"/>
-              <a:t>Auslaufen</a:t>
-            </a:r>
-            <a:r>
-              <a:rPr dirty="0"/>
-              <a:t> = Leakage; </a:t>
-            </a:r>
-            <a:r>
-              <a:rPr dirty="0" err="1"/>
-              <a:t>niedrig</a:t>
-            </a:r>
-            <a:r>
-              <a:rPr dirty="0"/>
-              <a:t> = </a:t>
-            </a:r>
-            <a:r>
-              <a:rPr dirty="0" err="1"/>
-              <a:t>sauber</a:t>
-            </a:r>
-            <a:r>
-              <a:rPr dirty="0"/>
-              <a:t>.</a:t>
-            </a:r>
-          </a:p>
-          <a:p>
-            <a:r>
-              <a:rPr dirty="0"/>
-              <a:t>• </a:t>
-            </a:r>
-            <a:r>
-              <a:rPr dirty="0" err="1"/>
-              <a:t>Naturgesetz</a:t>
-            </a:r>
-            <a:r>
-              <a:rPr dirty="0"/>
-              <a:t>: </a:t>
-            </a:r>
-            <a:r>
-              <a:rPr dirty="0" err="1"/>
-              <a:t>schmaler</a:t>
-            </a:r>
-            <a:r>
-              <a:rPr dirty="0"/>
-              <a:t> </a:t>
-            </a:r>
-            <a:r>
-              <a:rPr dirty="0" err="1"/>
-              <a:t>bedeutet</a:t>
-            </a:r>
-            <a:r>
-              <a:rPr dirty="0"/>
-              <a:t> </a:t>
-            </a:r>
-            <a:r>
-              <a:rPr dirty="0" err="1"/>
-              <a:t>höhere</a:t>
-            </a:r>
-            <a:r>
-              <a:rPr dirty="0"/>
-              <a:t> </a:t>
-            </a:r>
-            <a:r>
-              <a:rPr dirty="0" err="1"/>
-              <a:t>Nebenkeulen</a:t>
-            </a:r>
-            <a:r>
-              <a:rPr dirty="0"/>
-              <a:t> – immer </a:t>
-            </a:r>
-            <a:r>
-              <a:rPr dirty="0" err="1"/>
-              <a:t>ein</a:t>
-            </a:r>
-            <a:r>
-              <a:rPr dirty="0"/>
-              <a:t> </a:t>
-            </a:r>
-            <a:r>
-              <a:rPr dirty="0" err="1"/>
-              <a:t>Kompromiss</a:t>
-            </a:r>
-            <a:r>
-              <a:rPr dirty="0"/>
-              <a:t>.</a:t>
-            </a:r>
-          </a:p>
-          <a:p>
-            <a:r>
-              <a:rPr dirty="0"/>
-              <a:t>• </a:t>
-            </a:r>
-            <a:r>
-              <a:rPr dirty="0" err="1"/>
-              <a:t>Rechteck</a:t>
-            </a:r>
-            <a:r>
-              <a:rPr dirty="0"/>
-              <a:t> = „</a:t>
-            </a:r>
-            <a:r>
-              <a:rPr dirty="0" err="1"/>
-              <a:t>kein</a:t>
-            </a:r>
-            <a:r>
-              <a:rPr dirty="0"/>
-              <a:t> Fenster“ (</a:t>
-            </a:r>
-            <a:r>
-              <a:rPr dirty="0" err="1"/>
-              <a:t>Negativbeispiel</a:t>
-            </a:r>
-            <a:r>
-              <a:rPr dirty="0"/>
-              <a:t>), Flat-Top = </a:t>
-            </a:r>
-            <a:r>
-              <a:rPr dirty="0" err="1"/>
-              <a:t>extrem</a:t>
-            </a:r>
-            <a:r>
-              <a:rPr dirty="0"/>
-              <a:t> </a:t>
-            </a:r>
-            <a:r>
-              <a:rPr dirty="0" err="1"/>
-              <a:t>sauber</a:t>
-            </a:r>
-            <a:r>
-              <a:rPr dirty="0"/>
-              <a:t>, </a:t>
-            </a:r>
-            <a:r>
-              <a:rPr dirty="0" err="1"/>
-              <a:t>aber</a:t>
-            </a:r>
-            <a:r>
-              <a:rPr dirty="0"/>
-              <a:t> </a:t>
-            </a:r>
-            <a:r>
-              <a:rPr dirty="0" err="1"/>
-              <a:t>sehr</a:t>
-            </a:r>
-            <a:r>
-              <a:rPr dirty="0"/>
-              <a:t> </a:t>
-            </a:r>
-            <a:r>
-              <a:rPr dirty="0" err="1"/>
-              <a:t>breit</a:t>
-            </a:r>
-            <a:r>
-              <a:rPr dirty="0"/>
-              <a:t>.</a:t>
-            </a:r>
-          </a:p>
-          <a:p>
-            <a:endParaRPr dirty="0"/>
-          </a:p>
-          <a:p>
-            <a:r>
-              <a:rPr dirty="0" err="1"/>
-              <a:t>Überleitung</a:t>
-            </a:r>
-            <a:r>
-              <a:rPr dirty="0"/>
-              <a:t>: „</a:t>
-            </a:r>
-            <a:r>
-              <a:rPr dirty="0" err="1"/>
-              <a:t>Genug</a:t>
-            </a:r>
-            <a:r>
-              <a:rPr dirty="0"/>
-              <a:t> </a:t>
-            </a:r>
-            <a:r>
-              <a:rPr dirty="0" err="1"/>
-              <a:t>Theorie</a:t>
-            </a:r>
-            <a:r>
-              <a:rPr dirty="0"/>
-              <a:t> – </a:t>
-            </a:r>
-            <a:r>
-              <a:rPr dirty="0" err="1"/>
-              <a:t>schauen</a:t>
-            </a:r>
-            <a:r>
-              <a:rPr dirty="0"/>
-              <a:t> </a:t>
-            </a:r>
-            <a:r>
-              <a:rPr dirty="0" err="1"/>
-              <a:t>wir</a:t>
-            </a:r>
-            <a:r>
-              <a:rPr dirty="0"/>
-              <a:t> es </a:t>
-            </a:r>
-            <a:r>
-              <a:rPr dirty="0" err="1"/>
-              <a:t>uns</a:t>
-            </a:r>
-            <a:r>
-              <a:rPr dirty="0"/>
-              <a:t> </a:t>
-            </a:r>
-            <a:r>
-              <a:rPr dirty="0" err="1"/>
-              <a:t>direkt</a:t>
-            </a:r>
-            <a:r>
-              <a:rPr dirty="0"/>
-              <a:t> in MATLAB an.“</a:t>
+              <a:t>(ca. 6:45–7:30) Die Kernaussage in einem Satz.</a:t>
+            </a:r>
+          </a:p>
+          <a:p>
+            <a:endParaRPr/>
+          </a:p>
+          <a:p>
+            <a:r>
+              <a:t>• Das HRV-Signal hat starke langsame und nur schwache schnelle Anteile.</a:t>
+            </a:r>
+          </a:p>
+          <a:p>
+            <a:r>
+              <a:t>• Das Rechteck lässt die starke langsame Energie ins HF-Band lecken → HF wird ~4× zu groß.</a:t>
+            </a:r>
+          </a:p>
+          <a:p>
+            <a:r>
+              <a:t>• Damit kippt auch LF/HF – und das ist eine Zahl, die man medizinisch interpretiert.</a:t>
+            </a:r>
+          </a:p>
+          <a:p>
+            <a:r>
+              <a:t>• Botschaft: Die Fensterwahl ist keine Kosmetik, sie ändert das Ergebnis.</a:t>
             </a:r>
           </a:p>
         </p:txBody>
@@ -1411,676 +666,6 @@
 </file>
 
 <file path=ppt/notesSlides/notesSlide5.xml><?xml version="1.0" encoding="utf-8"?>
-<p:notes xmlns:a="http://schemas.openxmlformats.org/drawingml/2006/main" xmlns:r="http://schemas.openxmlformats.org/officeDocument/2006/relationships" xmlns:p="http://schemas.openxmlformats.org/presentationml/2006/main">
-  <p:cSld>
-    <p:spTree>
-      <p:nvGrpSpPr>
-        <p:cNvPr id="1" name=""/>
-        <p:cNvGrpSpPr/>
-        <p:nvPr/>
-      </p:nvGrpSpPr>
-      <p:grpSpPr>
-        <a:xfrm>
-          <a:off x="0" y="0"/>
-          <a:ext cx="0" cy="0"/>
-          <a:chOff x="0" y="0"/>
-          <a:chExt cx="0" cy="0"/>
-        </a:xfrm>
-      </p:grpSpPr>
-      <p:sp>
-        <p:nvSpPr>
-          <p:cNvPr id="2" name="Slide Image Placeholder 1"/>
-          <p:cNvSpPr>
-            <a:spLocks noGrp="1" noRot="1" noChangeAspect="1"/>
-          </p:cNvSpPr>
-          <p:nvPr>
-            <p:ph type="sldImg" idx="2"/>
-          </p:nvPr>
-        </p:nvSpPr>
-        <p:spPr/>
-      </p:sp>
-      <p:sp>
-        <p:nvSpPr>
-          <p:cNvPr id="3" name="Notes Placeholder 2"/>
-          <p:cNvSpPr>
-            <a:spLocks noGrp="1"/>
-          </p:cNvSpPr>
-          <p:nvPr>
-            <p:ph type="body" sz="quarter" idx="3"/>
-          </p:nvPr>
-        </p:nvSpPr>
-        <p:spPr/>
-        <p:txBody>
-          <a:bodyPr/>
-          <a:lstStyle/>
-          <a:p>
-            <a:r>
-              <a:rPr dirty="0"/>
-              <a:t>(ca. 4:15–6:45) HERZSTÜCK – ca. 2,5 Min. Ruhig und </a:t>
-            </a:r>
-            <a:r>
-              <a:rPr dirty="0" err="1"/>
-              <a:t>gezielt</a:t>
-            </a:r>
-            <a:r>
-              <a:rPr dirty="0"/>
-              <a:t> </a:t>
-            </a:r>
-            <a:r>
-              <a:rPr dirty="0" err="1"/>
-              <a:t>klicken</a:t>
-            </a:r>
-            <a:r>
-              <a:rPr dirty="0"/>
-              <a:t>, nicht </a:t>
-            </a:r>
-            <a:r>
-              <a:rPr dirty="0" err="1"/>
-              <a:t>hetzen</a:t>
-            </a:r>
-            <a:r>
-              <a:rPr dirty="0"/>
-              <a:t>.</a:t>
-            </a:r>
-          </a:p>
-          <a:p>
-            <a:endParaRPr dirty="0"/>
-          </a:p>
-          <a:p>
-            <a:r>
-              <a:rPr dirty="0"/>
-              <a:t>Roter Faden </a:t>
-            </a:r>
-            <a:r>
-              <a:rPr dirty="0" err="1"/>
-              <a:t>fuers</a:t>
-            </a:r>
-            <a:r>
-              <a:rPr dirty="0"/>
-              <a:t> </a:t>
-            </a:r>
-            <a:r>
-              <a:rPr dirty="0" err="1"/>
-              <a:t>Publikum</a:t>
-            </a:r>
-            <a:r>
-              <a:rPr dirty="0"/>
-              <a:t>:</a:t>
-            </a:r>
-          </a:p>
-          <a:p>
-            <a:r>
-              <a:rPr dirty="0"/>
-              <a:t>1) Kurz die </a:t>
-            </a:r>
-            <a:r>
-              <a:rPr dirty="0" err="1"/>
-              <a:t>modulare</a:t>
-            </a:r>
-            <a:r>
-              <a:rPr dirty="0"/>
-              <a:t> </a:t>
-            </a:r>
-            <a:r>
-              <a:rPr dirty="0" err="1"/>
-              <a:t>Struktur</a:t>
-            </a:r>
-            <a:r>
-              <a:rPr dirty="0"/>
-              <a:t> (</a:t>
-            </a:r>
-            <a:r>
-              <a:rPr dirty="0" err="1"/>
-              <a:t>eine</a:t>
-            </a:r>
-            <a:r>
-              <a:rPr dirty="0"/>
-              <a:t> </a:t>
-            </a:r>
-            <a:r>
-              <a:rPr dirty="0" err="1"/>
-              <a:t>Funktion</a:t>
-            </a:r>
-            <a:r>
-              <a:rPr dirty="0"/>
-              <a:t> je Pipeline-Schritt).</a:t>
-            </a:r>
-          </a:p>
-          <a:p>
-            <a:r>
-              <a:rPr dirty="0"/>
-              <a:t>2) Start – </a:t>
-            </a:r>
-            <a:r>
-              <a:rPr dirty="0" err="1"/>
-              <a:t>während</a:t>
-            </a:r>
-            <a:r>
-              <a:rPr dirty="0"/>
-              <a:t> es </a:t>
-            </a:r>
-            <a:r>
-              <a:rPr dirty="0" err="1"/>
-              <a:t>läuft</a:t>
-            </a:r>
-            <a:r>
-              <a:rPr dirty="0"/>
-              <a:t>: </a:t>
-            </a:r>
-            <a:r>
-              <a:rPr dirty="0" err="1"/>
-              <a:t>Konsolenausgabe</a:t>
-            </a:r>
-            <a:r>
-              <a:rPr dirty="0"/>
-              <a:t> </a:t>
-            </a:r>
-            <a:r>
-              <a:rPr dirty="0" err="1"/>
-              <a:t>kommentieren</a:t>
-            </a:r>
-            <a:r>
-              <a:rPr dirty="0"/>
-              <a:t> (fs, Dauer, R-</a:t>
-            </a:r>
-            <a:r>
-              <a:rPr dirty="0" err="1"/>
-              <a:t>Zacken</a:t>
-            </a:r>
-            <a:r>
-              <a:rPr dirty="0"/>
-              <a:t>, </a:t>
-            </a:r>
-            <a:r>
-              <a:rPr dirty="0" err="1"/>
-              <a:t>Artefakte</a:t>
-            </a:r>
-            <a:r>
-              <a:rPr dirty="0"/>
-              <a:t>).</a:t>
-            </a:r>
-          </a:p>
-          <a:p>
-            <a:r>
-              <a:rPr dirty="0"/>
-              <a:t>3) </a:t>
-            </a:r>
-            <a:r>
-              <a:rPr dirty="0" err="1"/>
-              <a:t>Vorverarbeitung</a:t>
-            </a:r>
-            <a:r>
-              <a:rPr dirty="0"/>
-              <a:t>: Baseline </a:t>
-            </a:r>
-            <a:r>
-              <a:rPr dirty="0" err="1"/>
-              <a:t>weg</a:t>
-            </a:r>
-            <a:r>
-              <a:rPr dirty="0"/>
-              <a:t>, Signal </a:t>
-            </a:r>
-            <a:r>
-              <a:rPr dirty="0" err="1"/>
-              <a:t>sauber</a:t>
-            </a:r>
-            <a:r>
-              <a:rPr dirty="0"/>
-              <a:t>; R-</a:t>
-            </a:r>
-            <a:r>
-              <a:rPr dirty="0" err="1"/>
-              <a:t>Zacken</a:t>
-            </a:r>
-            <a:r>
-              <a:rPr dirty="0"/>
-              <a:t> </a:t>
-            </a:r>
-            <a:r>
-              <a:rPr dirty="0" err="1"/>
-              <a:t>sitzen</a:t>
-            </a:r>
-            <a:r>
-              <a:rPr dirty="0"/>
-              <a:t> </a:t>
-            </a:r>
-            <a:r>
-              <a:rPr dirty="0" err="1"/>
-              <a:t>genau</a:t>
-            </a:r>
-            <a:r>
-              <a:rPr dirty="0"/>
-              <a:t> auf den </a:t>
-            </a:r>
-            <a:r>
-              <a:rPr dirty="0" err="1"/>
-              <a:t>Spitzen</a:t>
-            </a:r>
-            <a:r>
-              <a:rPr dirty="0"/>
-              <a:t>.</a:t>
-            </a:r>
-          </a:p>
-          <a:p>
-            <a:r>
-              <a:rPr dirty="0"/>
-              <a:t>4) </a:t>
-            </a:r>
-            <a:r>
-              <a:rPr dirty="0" err="1"/>
-              <a:t>Tachogramm</a:t>
-            </a:r>
-            <a:r>
-              <a:rPr dirty="0"/>
-              <a:t>: </a:t>
-            </a:r>
-            <a:r>
-              <a:rPr dirty="0" err="1"/>
-              <a:t>echte</a:t>
-            </a:r>
-            <a:r>
-              <a:rPr dirty="0"/>
-              <a:t> HRV-Dynamik.</a:t>
-            </a:r>
-          </a:p>
-          <a:p>
-            <a:r>
-              <a:rPr dirty="0"/>
-              <a:t>5) </a:t>
-            </a:r>
-            <a:r>
-              <a:rPr dirty="0" err="1"/>
-              <a:t>Fensterbilder</a:t>
-            </a:r>
-            <a:r>
-              <a:rPr dirty="0"/>
-              <a:t>: </a:t>
-            </a:r>
-            <a:r>
-              <a:rPr dirty="0" err="1"/>
-              <a:t>Rechteck</a:t>
-            </a:r>
-            <a:r>
-              <a:rPr dirty="0"/>
-              <a:t> </a:t>
-            </a:r>
-            <a:r>
-              <a:rPr dirty="0" err="1"/>
-              <a:t>breite</a:t>
-            </a:r>
-            <a:r>
-              <a:rPr dirty="0"/>
-              <a:t>/</a:t>
-            </a:r>
-            <a:r>
-              <a:rPr dirty="0" err="1"/>
-              <a:t>hohe</a:t>
-            </a:r>
-            <a:r>
-              <a:rPr dirty="0"/>
-              <a:t> </a:t>
-            </a:r>
-            <a:r>
-              <a:rPr dirty="0" err="1"/>
-              <a:t>Nebenkeulen</a:t>
-            </a:r>
-            <a:r>
-              <a:rPr dirty="0"/>
-              <a:t>, Flat-Top </a:t>
-            </a:r>
-            <a:r>
-              <a:rPr dirty="0" err="1"/>
-              <a:t>sehr</a:t>
-            </a:r>
-            <a:r>
-              <a:rPr dirty="0"/>
-              <a:t> </a:t>
-            </a:r>
-            <a:r>
-              <a:rPr dirty="0" err="1"/>
-              <a:t>niedrig</a:t>
-            </a:r>
-            <a:r>
-              <a:rPr dirty="0"/>
-              <a:t> </a:t>
-            </a:r>
-            <a:r>
-              <a:rPr dirty="0" err="1"/>
-              <a:t>aber</a:t>
-            </a:r>
-            <a:r>
-              <a:rPr dirty="0"/>
-              <a:t> </a:t>
-            </a:r>
-            <a:r>
-              <a:rPr dirty="0" err="1"/>
-              <a:t>breit</a:t>
-            </a:r>
-            <a:r>
-              <a:rPr dirty="0"/>
-              <a:t>.</a:t>
-            </a:r>
-          </a:p>
-          <a:p>
-            <a:r>
-              <a:rPr dirty="0"/>
-              <a:t>6) WICHTIGSTE Folie live: dB-Spektrum – </a:t>
-            </a:r>
-            <a:r>
-              <a:rPr dirty="0" err="1"/>
-              <a:t>Rechteck</a:t>
-            </a:r>
-            <a:r>
-              <a:rPr dirty="0"/>
-              <a:t> (</a:t>
-            </a:r>
-            <a:r>
-              <a:rPr dirty="0" err="1"/>
-              <a:t>blau</a:t>
-            </a:r>
-            <a:r>
-              <a:rPr dirty="0"/>
-              <a:t>) </a:t>
-            </a:r>
-            <a:r>
-              <a:rPr dirty="0" err="1"/>
-              <a:t>liegt</a:t>
-            </a:r>
-            <a:r>
-              <a:rPr dirty="0"/>
-              <a:t> </a:t>
-            </a:r>
-            <a:r>
-              <a:rPr dirty="0" err="1"/>
-              <a:t>oben</a:t>
-            </a:r>
-            <a:r>
-              <a:rPr dirty="0"/>
-              <a:t> (Leakage-Boden), Flat-Top (</a:t>
-            </a:r>
-            <a:r>
-              <a:rPr dirty="0" err="1"/>
-              <a:t>hellblau</a:t>
-            </a:r>
-            <a:r>
-              <a:rPr dirty="0"/>
-              <a:t>) </a:t>
-            </a:r>
-            <a:r>
-              <a:rPr dirty="0" err="1"/>
-              <a:t>unten</a:t>
-            </a:r>
-            <a:r>
-              <a:rPr dirty="0"/>
-              <a:t> (</a:t>
-            </a:r>
-            <a:r>
-              <a:rPr dirty="0" err="1"/>
-              <a:t>sauber</a:t>
-            </a:r>
-            <a:r>
-              <a:rPr dirty="0"/>
-              <a:t>).</a:t>
-            </a:r>
-          </a:p>
-          <a:p>
-            <a:r>
-              <a:rPr dirty="0"/>
-              <a:t>7) </a:t>
-            </a:r>
-            <a:r>
-              <a:rPr dirty="0" err="1"/>
-              <a:t>Wasserfälle</a:t>
-            </a:r>
-            <a:r>
-              <a:rPr dirty="0"/>
-              <a:t> </a:t>
-            </a:r>
-            <a:r>
-              <a:rPr dirty="0" err="1"/>
-              <a:t>vergleichen</a:t>
-            </a:r>
-            <a:r>
-              <a:rPr dirty="0"/>
-              <a:t> – </a:t>
-            </a:r>
-            <a:r>
-              <a:rPr dirty="0" err="1"/>
-              <a:t>einheitliche</a:t>
-            </a:r>
-            <a:r>
-              <a:rPr dirty="0"/>
-              <a:t> Skala </a:t>
-            </a:r>
-            <a:r>
-              <a:rPr dirty="0" err="1"/>
-              <a:t>betonen</a:t>
-            </a:r>
-            <a:r>
-              <a:rPr dirty="0"/>
-              <a:t>.</a:t>
-            </a:r>
-          </a:p>
-          <a:p>
-            <a:r>
-              <a:rPr dirty="0"/>
-              <a:t>8) </a:t>
-            </a:r>
-            <a:r>
-              <a:rPr dirty="0" err="1"/>
-              <a:t>Tabelle</a:t>
-            </a:r>
-            <a:r>
-              <a:rPr dirty="0"/>
-              <a:t>: auf HF und LF/HF </a:t>
-            </a:r>
-            <a:r>
-              <a:rPr dirty="0" err="1"/>
-              <a:t>zeigen</a:t>
-            </a:r>
-            <a:r>
-              <a:rPr dirty="0"/>
-              <a:t> (</a:t>
-            </a:r>
-            <a:r>
-              <a:rPr dirty="0" err="1"/>
-              <a:t>Überleitung</a:t>
-            </a:r>
-            <a:r>
-              <a:rPr dirty="0"/>
-              <a:t> </a:t>
-            </a:r>
-            <a:r>
-              <a:rPr dirty="0" err="1"/>
-              <a:t>zur</a:t>
-            </a:r>
-            <a:r>
-              <a:rPr dirty="0"/>
-              <a:t> </a:t>
-            </a:r>
-            <a:r>
-              <a:rPr dirty="0" err="1"/>
-              <a:t>nächsten</a:t>
-            </a:r>
-            <a:r>
-              <a:rPr dirty="0"/>
-              <a:t> Folie).</a:t>
-            </a:r>
-          </a:p>
-          <a:p>
-            <a:endParaRPr dirty="0"/>
-          </a:p>
-          <a:p>
-            <a:r>
-              <a:rPr dirty="0"/>
-              <a:t>FALLBACK: Falls MATLAB </a:t>
-            </a:r>
-            <a:r>
-              <a:rPr dirty="0" err="1"/>
-              <a:t>zickt</a:t>
-            </a:r>
-            <a:r>
-              <a:rPr dirty="0"/>
-              <a:t> – </a:t>
-            </a:r>
-            <a:r>
-              <a:rPr dirty="0" err="1"/>
-              <a:t>all_figures.pdf</a:t>
-            </a:r>
-            <a:r>
-              <a:rPr dirty="0"/>
-              <a:t> </a:t>
-            </a:r>
-            <a:r>
-              <a:rPr dirty="0" err="1"/>
-              <a:t>offen</a:t>
-            </a:r>
-            <a:r>
-              <a:rPr dirty="0"/>
-              <a:t> </a:t>
-            </a:r>
-            <a:r>
-              <a:rPr dirty="0" err="1"/>
-              <a:t>halten</a:t>
-            </a:r>
-            <a:r>
-              <a:rPr dirty="0"/>
-              <a:t> und </a:t>
-            </a:r>
-            <a:r>
-              <a:rPr dirty="0" err="1"/>
-              <a:t>daraus</a:t>
-            </a:r>
-            <a:r>
-              <a:rPr dirty="0"/>
-              <a:t> </a:t>
-            </a:r>
-            <a:r>
-              <a:rPr dirty="0" err="1"/>
-              <a:t>zeigen</a:t>
-            </a:r>
-            <a:r>
-              <a:rPr dirty="0"/>
-              <a:t>.</a:t>
-            </a:r>
-          </a:p>
-        </p:txBody>
-      </p:sp>
-      <p:sp>
-        <p:nvSpPr>
-          <p:cNvPr id="4" name="Slide Number Placeholder 3"/>
-          <p:cNvSpPr>
-            <a:spLocks noGrp="1"/>
-          </p:cNvSpPr>
-          <p:nvPr>
-            <p:ph type="sldNum" sz="quarter" idx="5"/>
-          </p:nvPr>
-        </p:nvSpPr>
-        <p:spPr/>
-      </p:sp>
-    </p:spTree>
-  </p:cSld>
-  <p:clrMapOvr>
-    <a:masterClrMapping/>
-  </p:clrMapOvr>
-</p:notes>
-</file>
-
-<file path=ppt/notesSlides/notesSlide6.xml><?xml version="1.0" encoding="utf-8"?>
-<p:notes xmlns:a="http://schemas.openxmlformats.org/drawingml/2006/main" xmlns:r="http://schemas.openxmlformats.org/officeDocument/2006/relationships" xmlns:p="http://schemas.openxmlformats.org/presentationml/2006/main">
-  <p:cSld>
-    <p:spTree>
-      <p:nvGrpSpPr>
-        <p:cNvPr id="1" name=""/>
-        <p:cNvGrpSpPr/>
-        <p:nvPr/>
-      </p:nvGrpSpPr>
-      <p:grpSpPr>
-        <a:xfrm>
-          <a:off x="0" y="0"/>
-          <a:ext cx="0" cy="0"/>
-          <a:chOff x="0" y="0"/>
-          <a:chExt cx="0" cy="0"/>
-        </a:xfrm>
-      </p:grpSpPr>
-      <p:sp>
-        <p:nvSpPr>
-          <p:cNvPr id="2" name="Slide Image Placeholder 1"/>
-          <p:cNvSpPr>
-            <a:spLocks noGrp="1" noRot="1" noChangeAspect="1"/>
-          </p:cNvSpPr>
-          <p:nvPr>
-            <p:ph type="sldImg" idx="2"/>
-          </p:nvPr>
-        </p:nvSpPr>
-        <p:spPr/>
-      </p:sp>
-      <p:sp>
-        <p:nvSpPr>
-          <p:cNvPr id="3" name="Notes Placeholder 2"/>
-          <p:cNvSpPr>
-            <a:spLocks noGrp="1"/>
-          </p:cNvSpPr>
-          <p:nvPr>
-            <p:ph type="body" sz="quarter" idx="3"/>
-          </p:nvPr>
-        </p:nvSpPr>
-        <p:spPr/>
-        <p:txBody>
-          <a:bodyPr/>
-          <a:lstStyle/>
-          <a:p>
-            <a:r>
-              <a:t>(ca. 6:45–7:30) Die Kernaussage in einem Satz.</a:t>
-            </a:r>
-          </a:p>
-          <a:p>
-            <a:endParaRPr/>
-          </a:p>
-          <a:p>
-            <a:r>
-              <a:t>• Das HRV-Signal hat starke langsame und nur schwache schnelle Anteile.</a:t>
-            </a:r>
-          </a:p>
-          <a:p>
-            <a:r>
-              <a:t>• Das Rechteck lässt die starke langsame Energie ins HF-Band lecken → HF wird ~4× zu groß.</a:t>
-            </a:r>
-          </a:p>
-          <a:p>
-            <a:r>
-              <a:t>• Damit kippt auch LF/HF – und das ist eine Zahl, die man medizinisch interpretiert.</a:t>
-            </a:r>
-          </a:p>
-          <a:p>
-            <a:r>
-              <a:t>• Botschaft: Die Fensterwahl ist keine Kosmetik, sie ändert das Ergebnis.</a:t>
-            </a:r>
-          </a:p>
-        </p:txBody>
-      </p:sp>
-      <p:sp>
-        <p:nvSpPr>
-          <p:cNvPr id="4" name="Slide Number Placeholder 3"/>
-          <p:cNvSpPr>
-            <a:spLocks noGrp="1"/>
-          </p:cNvSpPr>
-          <p:nvPr>
-            <p:ph type="sldNum" sz="quarter" idx="5"/>
-          </p:nvPr>
-        </p:nvSpPr>
-        <p:spPr/>
-      </p:sp>
-    </p:spTree>
-  </p:cSld>
-  <p:clrMapOvr>
-    <a:masterClrMapping/>
-  </p:clrMapOvr>
-</p:notes>
-</file>
-
-<file path=ppt/notesSlides/notesSlide7.xml><?xml version="1.0" encoding="utf-8"?>
 <p:notes xmlns:a="http://schemas.openxmlformats.org/drawingml/2006/main" xmlns:r="http://schemas.openxmlformats.org/officeDocument/2006/relationships" xmlns:p="http://schemas.openxmlformats.org/presentationml/2006/main">
   <p:cSld>
     <p:spTree>
@@ -2202,7 +787,7 @@
 </p:notes>
 </file>
 
-<file path=ppt/notesSlides/notesSlide8.xml><?xml version="1.0" encoding="utf-8"?>
+<file path=ppt/notesSlides/notesSlide6.xml><?xml version="1.0" encoding="utf-8"?>
 <p:notes xmlns:a="http://schemas.openxmlformats.org/drawingml/2006/main" xmlns:r="http://schemas.openxmlformats.org/officeDocument/2006/relationships" xmlns:p="http://schemas.openxmlformats.org/presentationml/2006/main">
   <p:cSld>
     <p:spTree>
@@ -2382,7 +967,7 @@
 </p:notes>
 </file>
 
-<file path=ppt/notesSlides/notesSlide9.xml><?xml version="1.0" encoding="utf-8"?>
+<file path=ppt/notesSlides/notesSlide7.xml><?xml version="1.0" encoding="utf-8"?>
 <p:notes xmlns:a="http://schemas.openxmlformats.org/drawingml/2006/main" xmlns:r="http://schemas.openxmlformats.org/officeDocument/2006/relationships" xmlns:p="http://schemas.openxmlformats.org/presentationml/2006/main">
   <p:cSld>
     <p:spTree>
@@ -10006,22 +8591,13 @@
               </a:spcAft>
             </a:pPr>
             <a:r>
-              <a:rPr lang="de-DE" sz="2200" b="1" i="0" noProof="0">
-                <a:solidFill>
-                  <a:srgbClr val="D62828"/>
-                </a:solidFill>
-                <a:latin typeface="Arial"/>
-              </a:rPr>
-              <a:t>→  Welches </a:t>
-            </a:r>
-            <a:r>
               <a:rPr lang="de-DE" sz="2200" b="1" i="0" noProof="0" dirty="0">
                 <a:solidFill>
                   <a:srgbClr val="D62828"/>
                 </a:solidFill>
                 <a:latin typeface="Arial"/>
               </a:rPr>
-              <a:t>Fenster ist der beste Kompromiss?</a:t>
+              <a:t>→  Welches Fenster ist der beste Kompromiss?</a:t>
             </a:r>
           </a:p>
         </p:txBody>
@@ -10040,7 +8616,7 @@
     <p:bg>
       <p:bgPr>
         <a:solidFill>
-          <a:srgbClr val="FFFFFF"/>
+          <a:srgbClr val="1A2332"/>
         </a:solidFill>
         <a:effectLst/>
       </p:bgPr>
@@ -10061,14 +8637,59 @@
       </p:grpSpPr>
       <p:sp>
         <p:nvSpPr>
-          <p:cNvPr id="2" name="TextBox 1"/>
+          <p:cNvPr id="2" name="Rectangle 1"/>
+          <p:cNvSpPr/>
+          <p:nvPr/>
+        </p:nvSpPr>
+        <p:spPr>
+          <a:xfrm>
+            <a:off x="822960" y="868680"/>
+            <a:ext cx="1280160" cy="100584"/>
+          </a:xfrm>
+          <a:prstGeom prst="rect">
+            <a:avLst/>
+          </a:prstGeom>
+          <a:solidFill>
+            <a:srgbClr val="D62828"/>
+          </a:solidFill>
+          <a:ln>
+            <a:noFill/>
+          </a:ln>
+          <a:effectLst/>
+        </p:spPr>
+        <p:style>
+          <a:lnRef idx="1">
+            <a:schemeClr val="accent1"/>
+          </a:lnRef>
+          <a:fillRef idx="3">
+            <a:schemeClr val="accent1"/>
+          </a:fillRef>
+          <a:effectRef idx="2">
+            <a:schemeClr val="accent1"/>
+          </a:effectRef>
+          <a:fontRef idx="minor">
+            <a:schemeClr val="lt1"/>
+          </a:fontRef>
+        </p:style>
+        <p:txBody>
+          <a:bodyPr rtlCol="0" anchor="ctr"/>
+          <a:lstStyle/>
+          <a:p>
+            <a:pPr algn="ctr"/>
+            <a:endParaRPr/>
+          </a:p>
+        </p:txBody>
+      </p:sp>
+      <p:sp>
+        <p:nvSpPr>
+          <p:cNvPr id="3" name="TextBox 2"/>
           <p:cNvSpPr txBox="1"/>
           <p:nvPr/>
         </p:nvSpPr>
         <p:spPr>
           <a:xfrm>
-            <a:off x="640080" y="502920"/>
-            <a:ext cx="10972800" cy="1005840"/>
+            <a:off x="822960" y="1051560"/>
+            <a:ext cx="10515600" cy="1097280"/>
           </a:xfrm>
           <a:prstGeom prst="rect">
             <a:avLst/>
@@ -10090,713 +8711,56 @@
               </a:spcAft>
             </a:pPr>
             <a:r>
-              <a:rPr sz="3000" b="1" i="0">
-                <a:solidFill>
-                  <a:srgbClr val="1A2332"/>
-                </a:solidFill>
-                <a:latin typeface="Arial"/>
-              </a:rPr>
-              <a:t>Die Verarbeitungskette</a:t>
-            </a:r>
-          </a:p>
-        </p:txBody>
-      </p:sp>
-      <p:sp>
-        <p:nvSpPr>
-          <p:cNvPr id="3" name="Rectangle 2"/>
-          <p:cNvSpPr/>
-          <p:nvPr/>
-        </p:nvSpPr>
-        <p:spPr>
-          <a:xfrm>
-            <a:off x="658368" y="1170432"/>
-            <a:ext cx="1005840" cy="82296"/>
-          </a:xfrm>
-          <a:prstGeom prst="rect">
-            <a:avLst/>
-          </a:prstGeom>
-          <a:solidFill>
-            <a:srgbClr val="D62828"/>
-          </a:solidFill>
-          <a:ln>
-            <a:noFill/>
-          </a:ln>
-          <a:effectLst/>
-        </p:spPr>
-        <p:style>
-          <a:lnRef idx="1">
-            <a:schemeClr val="accent1"/>
-          </a:lnRef>
-          <a:fillRef idx="3">
-            <a:schemeClr val="accent1"/>
-          </a:fillRef>
-          <a:effectRef idx="2">
-            <a:schemeClr val="accent1"/>
-          </a:effectRef>
-          <a:fontRef idx="minor">
-            <a:schemeClr val="lt1"/>
-          </a:fontRef>
-        </p:style>
-        <p:txBody>
-          <a:bodyPr rtlCol="0" anchor="ctr"/>
-          <a:lstStyle/>
-          <a:p>
-            <a:pPr algn="ctr"/>
-            <a:endParaRPr/>
-          </a:p>
-        </p:txBody>
-      </p:sp>
-      <p:sp>
-        <p:nvSpPr>
-          <p:cNvPr id="5" name="Rounded Rectangle 4"/>
-          <p:cNvSpPr/>
-          <p:nvPr/>
-        </p:nvSpPr>
-        <p:spPr>
-          <a:xfrm>
-            <a:off x="566928" y="2331720"/>
-            <a:ext cx="3291840" cy="1143000"/>
-          </a:xfrm>
-          <a:prstGeom prst="roundRect">
-            <a:avLst/>
-          </a:prstGeom>
-          <a:solidFill>
-            <a:srgbClr val="F4F6F8"/>
-          </a:solidFill>
-          <a:ln w="19050">
-            <a:solidFill>
-              <a:srgbClr val="1A2332"/>
-            </a:solidFill>
-          </a:ln>
-          <a:effectLst/>
-        </p:spPr>
-        <p:style>
-          <a:lnRef idx="1">
-            <a:schemeClr val="accent1"/>
-          </a:lnRef>
-          <a:fillRef idx="3">
-            <a:schemeClr val="accent1"/>
-          </a:fillRef>
-          <a:effectRef idx="2">
-            <a:schemeClr val="accent1"/>
-          </a:effectRef>
-          <a:fontRef idx="minor">
-            <a:schemeClr val="lt1"/>
-          </a:fontRef>
-        </p:style>
-        <p:txBody>
-          <a:bodyPr wrap="square" lIns="73152" tIns="36576" rIns="73152" bIns="36576" rtlCol="0" anchor="ctr"/>
-          <a:lstStyle/>
-          <a:p>
-            <a:pPr algn="ctr">
-              <a:spcBef>
-                <a:spcPts val="0"/>
-              </a:spcBef>
-              <a:spcAft>
-                <a:spcPts val="0"/>
-              </a:spcAft>
-            </a:pPr>
-            <a:r>
-              <a:rPr sz="1400" b="1" i="0" dirty="0">
-                <a:solidFill>
-                  <a:srgbClr val="1A2332"/>
-                </a:solidFill>
-                <a:latin typeface="Arial"/>
-              </a:rPr>
-              <a:t>1  EKG laden
-(EDF-</a:t>
-            </a:r>
-            <a:r>
-              <a:rPr sz="1400" b="1" i="0" dirty="0" err="1">
-                <a:solidFill>
-                  <a:srgbClr val="1A2332"/>
-                </a:solidFill>
-                <a:latin typeface="Arial"/>
-              </a:rPr>
-              <a:t>Datei</a:t>
-            </a:r>
-            <a:r>
-              <a:rPr sz="1400" b="1" i="0" dirty="0">
-                <a:solidFill>
-                  <a:srgbClr val="1A2332"/>
-                </a:solidFill>
-                <a:latin typeface="Arial"/>
-              </a:rPr>
-              <a:t>)</a:t>
-            </a:r>
-          </a:p>
-        </p:txBody>
-      </p:sp>
-      <p:sp>
-        <p:nvSpPr>
-          <p:cNvPr id="6" name="Rounded Rectangle 5"/>
-          <p:cNvSpPr/>
-          <p:nvPr/>
-        </p:nvSpPr>
-        <p:spPr>
-          <a:xfrm>
-            <a:off x="4453128" y="2331720"/>
-            <a:ext cx="3291840" cy="1143000"/>
-          </a:xfrm>
-          <a:prstGeom prst="roundRect">
-            <a:avLst/>
-          </a:prstGeom>
-          <a:solidFill>
-            <a:srgbClr val="F4F6F8"/>
-          </a:solidFill>
-          <a:ln w="19050">
-            <a:solidFill>
-              <a:srgbClr val="1A2332"/>
-            </a:solidFill>
-          </a:ln>
-          <a:effectLst/>
-        </p:spPr>
-        <p:style>
-          <a:lnRef idx="1">
-            <a:schemeClr val="accent1"/>
-          </a:lnRef>
-          <a:fillRef idx="3">
-            <a:schemeClr val="accent1"/>
-          </a:fillRef>
-          <a:effectRef idx="2">
-            <a:schemeClr val="accent1"/>
-          </a:effectRef>
-          <a:fontRef idx="minor">
-            <a:schemeClr val="lt1"/>
-          </a:fontRef>
-        </p:style>
-        <p:txBody>
-          <a:bodyPr wrap="square" lIns="73152" tIns="36576" rIns="73152" bIns="36576" rtlCol="0" anchor="ctr"/>
-          <a:lstStyle/>
-          <a:p>
-            <a:pPr algn="ctr">
-              <a:spcBef>
-                <a:spcPts val="0"/>
-              </a:spcBef>
-              <a:spcAft>
-                <a:spcPts val="0"/>
-              </a:spcAft>
-            </a:pPr>
-            <a:r>
-              <a:rPr sz="1400" b="1" i="0">
-                <a:solidFill>
-                  <a:srgbClr val="1A2332"/>
-                </a:solidFill>
-                <a:latin typeface="Arial"/>
-              </a:rPr>
-              <a:t>2  Vorverarbeiten
-(DC, Baseline, 50 Hz, Rauschen)</a:t>
-            </a:r>
-          </a:p>
-        </p:txBody>
-      </p:sp>
-      <p:sp>
-        <p:nvSpPr>
-          <p:cNvPr id="7" name="Rounded Rectangle 6"/>
-          <p:cNvSpPr/>
-          <p:nvPr/>
-        </p:nvSpPr>
-        <p:spPr>
-          <a:xfrm>
-            <a:off x="8339327" y="2331720"/>
-            <a:ext cx="3291840" cy="1143000"/>
-          </a:xfrm>
-          <a:prstGeom prst="roundRect">
-            <a:avLst/>
-          </a:prstGeom>
-          <a:solidFill>
-            <a:srgbClr val="F4F6F8"/>
-          </a:solidFill>
-          <a:ln w="19050">
-            <a:solidFill>
-              <a:srgbClr val="1A2332"/>
-            </a:solidFill>
-          </a:ln>
-          <a:effectLst/>
-        </p:spPr>
-        <p:style>
-          <a:lnRef idx="1">
-            <a:schemeClr val="accent1"/>
-          </a:lnRef>
-          <a:fillRef idx="3">
-            <a:schemeClr val="accent1"/>
-          </a:fillRef>
-          <a:effectRef idx="2">
-            <a:schemeClr val="accent1"/>
-          </a:effectRef>
-          <a:fontRef idx="minor">
-            <a:schemeClr val="lt1"/>
-          </a:fontRef>
-        </p:style>
-        <p:txBody>
-          <a:bodyPr wrap="square" lIns="73152" tIns="36576" rIns="73152" bIns="36576" rtlCol="0" anchor="ctr"/>
-          <a:lstStyle/>
-          <a:p>
-            <a:pPr algn="ctr">
-              <a:spcBef>
-                <a:spcPts val="0"/>
-              </a:spcBef>
-              <a:spcAft>
-                <a:spcPts val="0"/>
-              </a:spcAft>
-            </a:pPr>
-            <a:r>
-              <a:rPr sz="1400" b="1" i="0">
-                <a:solidFill>
-                  <a:srgbClr val="1A2332"/>
-                </a:solidFill>
-                <a:latin typeface="Arial"/>
-              </a:rPr>
-              <a:t>3  R-Zacken +
-RR-Intervalle</a:t>
-            </a:r>
-          </a:p>
-        </p:txBody>
-      </p:sp>
-      <p:sp>
-        <p:nvSpPr>
-          <p:cNvPr id="8" name="Rounded Rectangle 7"/>
-          <p:cNvSpPr/>
-          <p:nvPr/>
-        </p:nvSpPr>
-        <p:spPr>
-          <a:xfrm>
-            <a:off x="8339327" y="4160520"/>
-            <a:ext cx="3291840" cy="1143000"/>
-          </a:xfrm>
-          <a:prstGeom prst="roundRect">
-            <a:avLst/>
-          </a:prstGeom>
-          <a:solidFill>
-            <a:srgbClr val="F4F6F8"/>
-          </a:solidFill>
-          <a:ln w="19050">
-            <a:solidFill>
-              <a:srgbClr val="1A2332"/>
-            </a:solidFill>
-          </a:ln>
-          <a:effectLst/>
-        </p:spPr>
-        <p:style>
-          <a:lnRef idx="1">
-            <a:schemeClr val="accent1"/>
-          </a:lnRef>
-          <a:fillRef idx="3">
-            <a:schemeClr val="accent1"/>
-          </a:fillRef>
-          <a:effectRef idx="2">
-            <a:schemeClr val="accent1"/>
-          </a:effectRef>
-          <a:fontRef idx="minor">
-            <a:schemeClr val="lt1"/>
-          </a:fontRef>
-        </p:style>
-        <p:txBody>
-          <a:bodyPr wrap="square" lIns="73152" tIns="36576" rIns="73152" bIns="36576" rtlCol="0" anchor="ctr"/>
-          <a:lstStyle/>
-          <a:p>
-            <a:pPr algn="ctr">
-              <a:spcBef>
-                <a:spcPts val="0"/>
-              </a:spcBef>
-              <a:spcAft>
-                <a:spcPts val="0"/>
-              </a:spcAft>
-            </a:pPr>
-            <a:r>
-              <a:rPr sz="1400" b="1" i="0">
-                <a:solidFill>
-                  <a:srgbClr val="1A2332"/>
-                </a:solidFill>
-                <a:latin typeface="Arial"/>
-              </a:rPr>
-              <a:t>4  Interpolation
-(gleichmäßig, 4 Hz)</a:t>
-            </a:r>
-          </a:p>
-        </p:txBody>
-      </p:sp>
-      <p:sp>
-        <p:nvSpPr>
-          <p:cNvPr id="9" name="Rounded Rectangle 8"/>
-          <p:cNvSpPr/>
-          <p:nvPr/>
-        </p:nvSpPr>
-        <p:spPr>
-          <a:xfrm>
-            <a:off x="4453128" y="4160520"/>
-            <a:ext cx="3291840" cy="1143000"/>
-          </a:xfrm>
-          <a:prstGeom prst="roundRect">
-            <a:avLst/>
-          </a:prstGeom>
-          <a:solidFill>
-            <a:srgbClr val="D62828"/>
-          </a:solidFill>
-          <a:ln w="19050">
-            <a:solidFill>
-              <a:srgbClr val="D62828"/>
-            </a:solidFill>
-          </a:ln>
-          <a:effectLst/>
-        </p:spPr>
-        <p:style>
-          <a:lnRef idx="1">
-            <a:schemeClr val="accent1"/>
-          </a:lnRef>
-          <a:fillRef idx="3">
-            <a:schemeClr val="accent1"/>
-          </a:fillRef>
-          <a:effectRef idx="2">
-            <a:schemeClr val="accent1"/>
-          </a:effectRef>
-          <a:fontRef idx="minor">
-            <a:schemeClr val="lt1"/>
-          </a:fontRef>
-        </p:style>
-        <p:txBody>
-          <a:bodyPr wrap="square" lIns="73152" tIns="36576" rIns="73152" bIns="36576" rtlCol="0" anchor="ctr"/>
-          <a:lstStyle/>
-          <a:p>
-            <a:pPr algn="ctr">
-              <a:spcBef>
-                <a:spcPts val="0"/>
-              </a:spcBef>
-              <a:spcAft>
-                <a:spcPts val="0"/>
-              </a:spcAft>
-            </a:pPr>
-            <a:r>
-              <a:rPr sz="1400" b="1" i="0">
+              <a:rPr sz="4600" b="1" i="0">
                 <a:solidFill>
                   <a:srgbClr val="FFFFFF"/>
                 </a:solidFill>
                 <a:latin typeface="Arial"/>
               </a:rPr>
-              <a:t>5  FFT × 6 Fenster
-(rect, hann, …, flattop)</a:t>
+              <a:t>LIVE-DEMO</a:t>
             </a:r>
           </a:p>
         </p:txBody>
       </p:sp>
       <p:sp>
         <p:nvSpPr>
-          <p:cNvPr id="10" name="Rounded Rectangle 9"/>
-          <p:cNvSpPr/>
+          <p:cNvPr id="4" name="TextBox 3"/>
+          <p:cNvSpPr txBox="1"/>
           <p:nvPr/>
         </p:nvSpPr>
         <p:spPr>
           <a:xfrm>
-            <a:off x="566928" y="4160520"/>
-            <a:ext cx="3291840" cy="1143000"/>
-          </a:xfrm>
-          <a:prstGeom prst="roundRect">
-            <a:avLst/>
-          </a:prstGeom>
-          <a:solidFill>
-            <a:srgbClr val="F4F6F8"/>
-          </a:solidFill>
-          <a:ln w="19050">
-            <a:solidFill>
-              <a:srgbClr val="1A2332"/>
-            </a:solidFill>
-          </a:ln>
-          <a:effectLst/>
-        </p:spPr>
-        <p:style>
-          <a:lnRef idx="1">
-            <a:schemeClr val="accent1"/>
-          </a:lnRef>
-          <a:fillRef idx="3">
-            <a:schemeClr val="accent1"/>
-          </a:fillRef>
-          <a:effectRef idx="2">
-            <a:schemeClr val="accent1"/>
-          </a:effectRef>
-          <a:fontRef idx="minor">
-            <a:schemeClr val="lt1"/>
-          </a:fontRef>
-        </p:style>
+            <a:off x="822960" y="1965960"/>
+            <a:ext cx="10607040" cy="548640"/>
+          </a:xfrm>
+          <a:prstGeom prst="rect">
+            <a:avLst/>
+          </a:prstGeom>
+          <a:noFill/>
+        </p:spPr>
         <p:txBody>
-          <a:bodyPr wrap="square" lIns="73152" tIns="36576" rIns="73152" bIns="36576" rtlCol="0" anchor="ctr"/>
+          <a:bodyPr wrap="square" lIns="0" tIns="0" rIns="0" bIns="0" anchor="t">
+            <a:spAutoFit/>
+          </a:bodyPr>
           <a:lstStyle/>
           <a:p>
-            <a:pPr algn="ctr">
+            <a:pPr algn="l">
               <a:spcBef>
                 <a:spcPts val="0"/>
               </a:spcBef>
               <a:spcAft>
-                <a:spcPts val="0"/>
+                <a:spcPts val="600"/>
               </a:spcAft>
             </a:pPr>
             <a:r>
-              <a:rPr sz="1400" b="1" i="0" dirty="0">
+              <a:rPr sz="1800" b="0" i="0">
                 <a:solidFill>
-                  <a:srgbClr val="1A2332"/>
+                  <a:srgbClr val="B8C2CC"/>
                 </a:solidFill>
                 <a:latin typeface="Arial"/>
               </a:rPr>
-              <a:t>6  HRV-</a:t>
-            </a:r>
-            <a:r>
-              <a:rPr sz="1400" b="1" i="0" dirty="0" err="1">
-                <a:solidFill>
-                  <a:srgbClr val="1A2332"/>
-                </a:solidFill>
-                <a:latin typeface="Arial"/>
-              </a:rPr>
-              <a:t>Bänder</a:t>
-            </a:r>
-            <a:r>
-              <a:rPr sz="1400" b="1" i="0" dirty="0">
-                <a:solidFill>
-                  <a:srgbClr val="1A2332"/>
-                </a:solidFill>
-                <a:latin typeface="Arial"/>
-              </a:rPr>
-              <a:t> +
-</a:t>
-            </a:r>
-            <a:r>
-              <a:rPr sz="1400" b="1" i="0" dirty="0" err="1">
-                <a:solidFill>
-                  <a:srgbClr val="1A2332"/>
-                </a:solidFill>
-                <a:latin typeface="Arial"/>
-              </a:rPr>
-              <a:t>Wasserfall</a:t>
-            </a:r>
-            <a:endParaRPr sz="1400" b="1" i="0" dirty="0">
-              <a:solidFill>
-                <a:srgbClr val="1A2332"/>
-              </a:solidFill>
-              <a:latin typeface="Arial"/>
-            </a:endParaRPr>
-          </a:p>
-        </p:txBody>
-      </p:sp>
-      <p:sp>
-        <p:nvSpPr>
-          <p:cNvPr id="11" name="Right Arrow 10"/>
-          <p:cNvSpPr/>
-          <p:nvPr/>
-        </p:nvSpPr>
-        <p:spPr>
-          <a:xfrm>
-            <a:off x="3950207" y="2756915"/>
-            <a:ext cx="411480" cy="292608"/>
-          </a:xfrm>
-          <a:prstGeom prst="rightArrow">
-            <a:avLst/>
-          </a:prstGeom>
-          <a:solidFill>
-            <a:srgbClr val="6C7A89"/>
-          </a:solidFill>
-          <a:ln>
-            <a:noFill/>
-          </a:ln>
-          <a:effectLst/>
-        </p:spPr>
-        <p:style>
-          <a:lnRef idx="1">
-            <a:schemeClr val="accent1"/>
-          </a:lnRef>
-          <a:fillRef idx="3">
-            <a:schemeClr val="accent1"/>
-          </a:fillRef>
-          <a:effectRef idx="2">
-            <a:schemeClr val="accent1"/>
-          </a:effectRef>
-          <a:fontRef idx="minor">
-            <a:schemeClr val="lt1"/>
-          </a:fontRef>
-        </p:style>
-        <p:txBody>
-          <a:bodyPr rtlCol="0" anchor="ctr"/>
-          <a:lstStyle/>
-          <a:p>
-            <a:pPr algn="ctr"/>
-            <a:endParaRPr/>
-          </a:p>
-        </p:txBody>
-      </p:sp>
-      <p:sp>
-        <p:nvSpPr>
-          <p:cNvPr id="12" name="Right Arrow 11"/>
-          <p:cNvSpPr/>
-          <p:nvPr/>
-        </p:nvSpPr>
-        <p:spPr>
-          <a:xfrm>
-            <a:off x="7836408" y="2756915"/>
-            <a:ext cx="411480" cy="292608"/>
-          </a:xfrm>
-          <a:prstGeom prst="rightArrow">
-            <a:avLst/>
-          </a:prstGeom>
-          <a:solidFill>
-            <a:srgbClr val="6C7A89"/>
-          </a:solidFill>
-          <a:ln>
-            <a:noFill/>
-          </a:ln>
-          <a:effectLst/>
-        </p:spPr>
-        <p:style>
-          <a:lnRef idx="1">
-            <a:schemeClr val="accent1"/>
-          </a:lnRef>
-          <a:fillRef idx="3">
-            <a:schemeClr val="accent1"/>
-          </a:fillRef>
-          <a:effectRef idx="2">
-            <a:schemeClr val="accent1"/>
-          </a:effectRef>
-          <a:fontRef idx="minor">
-            <a:schemeClr val="lt1"/>
-          </a:fontRef>
-        </p:style>
-        <p:txBody>
-          <a:bodyPr rtlCol="0" anchor="ctr"/>
-          <a:lstStyle/>
-          <a:p>
-            <a:pPr algn="ctr"/>
-            <a:endParaRPr/>
-          </a:p>
-        </p:txBody>
-      </p:sp>
-      <p:sp>
-        <p:nvSpPr>
-          <p:cNvPr id="13" name="Down Arrow 12"/>
-          <p:cNvSpPr/>
-          <p:nvPr/>
-        </p:nvSpPr>
-        <p:spPr>
-          <a:xfrm>
-            <a:off x="9838944" y="3520439"/>
-            <a:ext cx="292608" cy="411480"/>
-          </a:xfrm>
-          <a:prstGeom prst="downArrow">
-            <a:avLst/>
-          </a:prstGeom>
-          <a:solidFill>
-            <a:srgbClr val="6C7A89"/>
-          </a:solidFill>
-          <a:ln>
-            <a:noFill/>
-          </a:ln>
-          <a:effectLst/>
-        </p:spPr>
-        <p:style>
-          <a:lnRef idx="1">
-            <a:schemeClr val="accent1"/>
-          </a:lnRef>
-          <a:fillRef idx="3">
-            <a:schemeClr val="accent1"/>
-          </a:fillRef>
-          <a:effectRef idx="2">
-            <a:schemeClr val="accent1"/>
-          </a:effectRef>
-          <a:fontRef idx="minor">
-            <a:schemeClr val="lt1"/>
-          </a:fontRef>
-        </p:style>
-        <p:txBody>
-          <a:bodyPr rtlCol="0" anchor="ctr"/>
-          <a:lstStyle/>
-          <a:p>
-            <a:pPr algn="ctr"/>
-            <a:endParaRPr/>
-          </a:p>
-        </p:txBody>
-      </p:sp>
-      <p:sp>
-        <p:nvSpPr>
-          <p:cNvPr id="14" name="Left Arrow 13"/>
-          <p:cNvSpPr/>
-          <p:nvPr/>
-        </p:nvSpPr>
-        <p:spPr>
-          <a:xfrm>
-            <a:off x="7836408" y="4585716"/>
-            <a:ext cx="411480" cy="292608"/>
-          </a:xfrm>
-          <a:prstGeom prst="leftArrow">
-            <a:avLst/>
-          </a:prstGeom>
-          <a:solidFill>
-            <a:srgbClr val="6C7A89"/>
-          </a:solidFill>
-          <a:ln>
-            <a:noFill/>
-          </a:ln>
-          <a:effectLst/>
-        </p:spPr>
-        <p:style>
-          <a:lnRef idx="1">
-            <a:schemeClr val="accent1"/>
-          </a:lnRef>
-          <a:fillRef idx="3">
-            <a:schemeClr val="accent1"/>
-          </a:fillRef>
-          <a:effectRef idx="2">
-            <a:schemeClr val="accent1"/>
-          </a:effectRef>
-          <a:fontRef idx="minor">
-            <a:schemeClr val="lt1"/>
-          </a:fontRef>
-        </p:style>
-        <p:txBody>
-          <a:bodyPr rtlCol="0" anchor="ctr"/>
-          <a:lstStyle/>
-          <a:p>
-            <a:pPr algn="ctr"/>
-            <a:endParaRPr/>
-          </a:p>
-        </p:txBody>
-      </p:sp>
-      <p:sp>
-        <p:nvSpPr>
-          <p:cNvPr id="15" name="Left Arrow 14"/>
-          <p:cNvSpPr/>
-          <p:nvPr/>
-        </p:nvSpPr>
-        <p:spPr>
-          <a:xfrm>
-            <a:off x="3950207" y="4585716"/>
-            <a:ext cx="411480" cy="292608"/>
-          </a:xfrm>
-          <a:prstGeom prst="leftArrow">
-            <a:avLst/>
-          </a:prstGeom>
-          <a:solidFill>
-            <a:srgbClr val="6C7A89"/>
-          </a:solidFill>
-          <a:ln>
-            <a:noFill/>
-          </a:ln>
-          <a:effectLst/>
-        </p:spPr>
-        <p:style>
-          <a:lnRef idx="1">
-            <a:schemeClr val="accent1"/>
-          </a:lnRef>
-          <a:fillRef idx="3">
-            <a:schemeClr val="accent1"/>
-          </a:fillRef>
-          <a:effectRef idx="2">
-            <a:schemeClr val="accent1"/>
-          </a:effectRef>
-          <a:fontRef idx="minor">
-            <a:schemeClr val="lt1"/>
-          </a:fontRef>
-        </p:style>
-        <p:txBody>
-          <a:bodyPr rtlCol="0" anchor="ctr"/>
-          <a:lstStyle/>
-          <a:p>
-            <a:pPr algn="ctr"/>
-            <a:endParaRPr/>
+              <a:t>MATLAB: Code-Struktur &amp; Ergebnisse</a:t>
+            </a:r>
           </a:p>
         </p:txBody>
       </p:sp>
@@ -10842,7 +8806,7 @@
         <p:spPr>
           <a:xfrm>
             <a:off x="640080" y="502920"/>
-            <a:ext cx="10972800" cy="1005840"/>
+            <a:ext cx="10972800" cy="461665"/>
           </a:xfrm>
           <a:prstGeom prst="rect">
             <a:avLst/>
@@ -10864,13 +8828,13 @@
               </a:spcAft>
             </a:pPr>
             <a:r>
-              <a:rPr sz="3000" b="1" i="0">
+              <a:rPr lang="de-DE" sz="3000" b="1" i="0" dirty="0">
                 <a:solidFill>
                   <a:srgbClr val="1A2332"/>
                 </a:solidFill>
                 <a:latin typeface="Arial"/>
               </a:rPr>
-              <a:t>Fensterfunktion = ein Kompromiss</a:t>
+              <a:t>Hauptkeulenunterschied</a:t>
             </a:r>
           </a:p>
         </p:txBody>
@@ -10920,457 +8884,66 @@
           </a:p>
         </p:txBody>
       </p:sp>
-      <p:sp>
-        <p:nvSpPr>
-          <p:cNvPr id="4" name="Rounded Rectangle 3"/>
-          <p:cNvSpPr/>
-          <p:nvPr/>
-        </p:nvSpPr>
-        <p:spPr>
-          <a:xfrm>
-            <a:off x="822960" y="2148840"/>
-            <a:ext cx="4937760" cy="1554480"/>
-          </a:xfrm>
-          <a:prstGeom prst="roundRect">
-            <a:avLst/>
-          </a:prstGeom>
-          <a:solidFill>
-            <a:srgbClr val="F4F6F8"/>
-          </a:solidFill>
-          <a:ln w="19050">
-            <a:solidFill>
-              <a:srgbClr val="1A2332"/>
-            </a:solidFill>
-          </a:ln>
-          <a:effectLst/>
-        </p:spPr>
-        <p:style>
-          <a:lnRef idx="1">
-            <a:schemeClr val="accent1"/>
-          </a:lnRef>
-          <a:fillRef idx="3">
-            <a:schemeClr val="accent1"/>
-          </a:fillRef>
-          <a:effectRef idx="2">
-            <a:schemeClr val="accent1"/>
-          </a:effectRef>
-          <a:fontRef idx="minor">
-            <a:schemeClr val="lt1"/>
-          </a:fontRef>
-        </p:style>
-        <p:txBody>
-          <a:bodyPr wrap="square" lIns="73152" tIns="36576" rIns="73152" bIns="36576" rtlCol="0" anchor="ctr"/>
-          <a:lstStyle/>
-          <a:p>
-            <a:pPr algn="ctr">
-              <a:spcBef>
-                <a:spcPts val="0"/>
-              </a:spcBef>
-              <a:spcAft>
-                <a:spcPts val="0"/>
-              </a:spcAft>
-            </a:pPr>
-            <a:r>
-              <a:rPr sz="1800" b="1" i="0">
-                <a:solidFill>
-                  <a:srgbClr val="1A2332"/>
-                </a:solidFill>
-                <a:latin typeface="Arial"/>
-              </a:rPr>
-              <a:t>Schmale Hauptkeule
-→ gute Frequenzauflösung</a:t>
-            </a:r>
-          </a:p>
-        </p:txBody>
-      </p:sp>
-      <p:sp>
-        <p:nvSpPr>
-          <p:cNvPr id="5" name="Rounded Rectangle 4"/>
-          <p:cNvSpPr/>
-          <p:nvPr/>
-        </p:nvSpPr>
-        <p:spPr>
-          <a:xfrm>
-            <a:off x="6446520" y="2148840"/>
-            <a:ext cx="4937760" cy="1554480"/>
-          </a:xfrm>
-          <a:prstGeom prst="roundRect">
-            <a:avLst/>
-          </a:prstGeom>
-          <a:solidFill>
-            <a:srgbClr val="F4F6F8"/>
-          </a:solidFill>
-          <a:ln w="19050">
-            <a:solidFill>
-              <a:srgbClr val="1A2332"/>
-            </a:solidFill>
-          </a:ln>
-          <a:effectLst/>
-        </p:spPr>
-        <p:style>
-          <a:lnRef idx="1">
-            <a:schemeClr val="accent1"/>
-          </a:lnRef>
-          <a:fillRef idx="3">
-            <a:schemeClr val="accent1"/>
-          </a:fillRef>
-          <a:effectRef idx="2">
-            <a:schemeClr val="accent1"/>
-          </a:effectRef>
-          <a:fontRef idx="minor">
-            <a:schemeClr val="lt1"/>
-          </a:fontRef>
-        </p:style>
-        <p:txBody>
-          <a:bodyPr wrap="square" lIns="73152" tIns="36576" rIns="73152" bIns="36576" rtlCol="0" anchor="ctr"/>
-          <a:lstStyle/>
-          <a:p>
-            <a:pPr algn="ctr">
-              <a:spcBef>
-                <a:spcPts val="0"/>
-              </a:spcBef>
-              <a:spcAft>
-                <a:spcPts val="0"/>
-              </a:spcAft>
-            </a:pPr>
-            <a:r>
-              <a:rPr sz="1800" b="1" i="0">
-                <a:solidFill>
-                  <a:srgbClr val="1A2332"/>
-                </a:solidFill>
-                <a:latin typeface="Arial"/>
-              </a:rPr>
-              <a:t>Niedrige Nebenkeulen
-→ wenig Leakage</a:t>
-            </a:r>
-          </a:p>
-        </p:txBody>
-      </p:sp>
-      <p:sp>
-        <p:nvSpPr>
-          <p:cNvPr id="6" name="TextBox 5"/>
-          <p:cNvSpPr txBox="1"/>
-          <p:nvPr/>
-        </p:nvSpPr>
-        <p:spPr>
-          <a:xfrm>
-            <a:off x="5760720" y="2651760"/>
-            <a:ext cx="777240" cy="640080"/>
+      <p:pic>
+        <p:nvPicPr>
+          <p:cNvPr id="10" name="Grafik 9">
+            <a:extLst>
+              <a:ext uri="{FF2B5EF4-FFF2-40B4-BE49-F238E27FC236}">
+                <a16:creationId xmlns:a16="http://schemas.microsoft.com/office/drawing/2014/main" id="{6E0C536B-7D84-20F0-EF43-1251F42B5C60}"/>
+              </a:ext>
+            </a:extLst>
+          </p:cNvPr>
+          <p:cNvPicPr>
+            <a:picLocks noChangeAspect="1"/>
+          </p:cNvPicPr>
+          <p:nvPr/>
+        </p:nvPicPr>
+        <p:blipFill>
+          <a:blip r:embed="rId3"/>
+          <a:stretch>
+            <a:fillRect/>
+          </a:stretch>
+        </p:blipFill>
+        <p:spPr>
+          <a:xfrm>
+            <a:off x="183882" y="1519693"/>
+            <a:ext cx="5786250" cy="3818614"/>
           </a:xfrm>
           <a:prstGeom prst="rect">
             <a:avLst/>
           </a:prstGeom>
-          <a:noFill/>
-        </p:spPr>
-        <p:txBody>
-          <a:bodyPr wrap="square" lIns="0" tIns="0" rIns="0" bIns="0" anchor="ctr">
-            <a:spAutoFit/>
-          </a:bodyPr>
-          <a:lstStyle/>
-          <a:p>
-            <a:pPr algn="ctr">
-              <a:spcBef>
-                <a:spcPts val="0"/>
-              </a:spcBef>
-              <a:spcAft>
-                <a:spcPts val="600"/>
-              </a:spcAft>
-            </a:pPr>
-            <a:r>
-              <a:rPr sz="3000" b="1" i="0">
-                <a:solidFill>
-                  <a:srgbClr val="D62828"/>
-                </a:solidFill>
-                <a:latin typeface="Arial"/>
-              </a:rPr>
-              <a:t>↔</a:t>
-            </a:r>
-          </a:p>
-        </p:txBody>
-      </p:sp>
-      <p:sp>
-        <p:nvSpPr>
-          <p:cNvPr id="7" name="TextBox 6"/>
-          <p:cNvSpPr txBox="1"/>
-          <p:nvPr/>
-        </p:nvSpPr>
-        <p:spPr>
-          <a:xfrm>
-            <a:off x="822960" y="3977639"/>
-            <a:ext cx="10607040" cy="615553"/>
+        </p:spPr>
+      </p:pic>
+      <p:pic>
+        <p:nvPicPr>
+          <p:cNvPr id="11" name="Grafik 10">
+            <a:extLst>
+              <a:ext uri="{FF2B5EF4-FFF2-40B4-BE49-F238E27FC236}">
+                <a16:creationId xmlns:a16="http://schemas.microsoft.com/office/drawing/2014/main" id="{E6E73D98-395F-3ABB-E8E2-5172BDAA8348}"/>
+              </a:ext>
+            </a:extLst>
+          </p:cNvPr>
+          <p:cNvPicPr>
+            <a:picLocks noChangeAspect="1"/>
+          </p:cNvPicPr>
+          <p:nvPr/>
+        </p:nvPicPr>
+        <p:blipFill>
+          <a:blip r:embed="rId4"/>
+          <a:stretch>
+            <a:fillRect/>
+          </a:stretch>
+        </p:blipFill>
+        <p:spPr>
+          <a:xfrm>
+            <a:off x="6096000" y="1540004"/>
+            <a:ext cx="5817360" cy="3798303"/>
           </a:xfrm>
           <a:prstGeom prst="rect">
             <a:avLst/>
           </a:prstGeom>
-          <a:noFill/>
-        </p:spPr>
-        <p:txBody>
-          <a:bodyPr wrap="square" lIns="0" tIns="0" rIns="0" bIns="0" anchor="t">
-            <a:spAutoFit/>
-          </a:bodyPr>
-          <a:lstStyle/>
-          <a:p>
-            <a:pPr algn="ctr">
-              <a:spcBef>
-                <a:spcPts val="0"/>
-              </a:spcBef>
-              <a:spcAft>
-                <a:spcPts val="600"/>
-              </a:spcAft>
-            </a:pPr>
-            <a:r>
-              <a:rPr sz="2000" b="1" i="0" dirty="0" err="1">
-                <a:solidFill>
-                  <a:srgbClr val="D62828"/>
-                </a:solidFill>
-                <a:latin typeface="Arial"/>
-              </a:rPr>
-              <a:t>Beides</a:t>
-            </a:r>
-            <a:r>
-              <a:rPr sz="2000" b="1" i="0" dirty="0">
-                <a:solidFill>
-                  <a:srgbClr val="D62828"/>
-                </a:solidFill>
-                <a:latin typeface="Arial"/>
-              </a:rPr>
-              <a:t> </a:t>
-            </a:r>
-            <a:r>
-              <a:rPr sz="2000" b="1" i="0" dirty="0" err="1">
-                <a:solidFill>
-                  <a:srgbClr val="D62828"/>
-                </a:solidFill>
-                <a:latin typeface="Arial"/>
-              </a:rPr>
-              <a:t>gleichzeitig</a:t>
-            </a:r>
-            <a:r>
-              <a:rPr sz="2000" b="1" i="0" dirty="0">
-                <a:solidFill>
-                  <a:srgbClr val="D62828"/>
-                </a:solidFill>
-                <a:latin typeface="Arial"/>
-              </a:rPr>
-              <a:t> </a:t>
-            </a:r>
-            <a:r>
-              <a:rPr sz="2000" b="1" i="0" dirty="0" err="1">
-                <a:solidFill>
-                  <a:srgbClr val="D62828"/>
-                </a:solidFill>
-                <a:latin typeface="Arial"/>
-              </a:rPr>
-              <a:t>geht</a:t>
-            </a:r>
-            <a:r>
-              <a:rPr sz="2000" b="1" i="0" dirty="0">
-                <a:solidFill>
-                  <a:srgbClr val="D62828"/>
-                </a:solidFill>
-                <a:latin typeface="Arial"/>
-              </a:rPr>
-              <a:t> nicht</a:t>
-            </a:r>
-            <a:r>
-              <a:rPr lang="de-DE" sz="2000" b="1" i="0" dirty="0">
-                <a:solidFill>
-                  <a:srgbClr val="D62828"/>
-                </a:solidFill>
-                <a:latin typeface="Arial"/>
-              </a:rPr>
-              <a:t>, </a:t>
-            </a:r>
-            <a:r>
-              <a:rPr sz="2000" b="1" i="0" dirty="0" err="1">
-                <a:solidFill>
-                  <a:srgbClr val="D62828"/>
-                </a:solidFill>
-                <a:latin typeface="Arial"/>
-              </a:rPr>
-              <a:t>jedes</a:t>
-            </a:r>
-            <a:r>
-              <a:rPr sz="2000" b="1" i="0" dirty="0">
-                <a:solidFill>
-                  <a:srgbClr val="D62828"/>
-                </a:solidFill>
-                <a:latin typeface="Arial"/>
-              </a:rPr>
-              <a:t> Fenster </a:t>
-            </a:r>
-            <a:r>
-              <a:rPr sz="2000" b="1" i="0" dirty="0" err="1">
-                <a:solidFill>
-                  <a:srgbClr val="D62828"/>
-                </a:solidFill>
-                <a:latin typeface="Arial"/>
-              </a:rPr>
-              <a:t>wählt</a:t>
-            </a:r>
-            <a:r>
-              <a:rPr sz="2000" b="1" i="0" dirty="0">
-                <a:solidFill>
-                  <a:srgbClr val="D62828"/>
-                </a:solidFill>
-                <a:latin typeface="Arial"/>
-              </a:rPr>
-              <a:t> </a:t>
-            </a:r>
-            <a:r>
-              <a:rPr sz="2000" b="1" i="0" dirty="0" err="1">
-                <a:solidFill>
-                  <a:srgbClr val="D62828"/>
-                </a:solidFill>
-                <a:latin typeface="Arial"/>
-              </a:rPr>
-              <a:t>einen</a:t>
-            </a:r>
-            <a:r>
-              <a:rPr sz="2000" b="1" i="0" dirty="0">
-                <a:solidFill>
-                  <a:srgbClr val="D62828"/>
-                </a:solidFill>
-                <a:latin typeface="Arial"/>
-              </a:rPr>
-              <a:t> </a:t>
-            </a:r>
-            <a:r>
-              <a:rPr sz="2000" b="1" i="0" dirty="0" err="1">
-                <a:solidFill>
-                  <a:srgbClr val="D62828"/>
-                </a:solidFill>
-                <a:latin typeface="Arial"/>
-              </a:rPr>
-              <a:t>anderen</a:t>
-            </a:r>
-            <a:r>
-              <a:rPr sz="2000" b="1" i="0" dirty="0">
-                <a:solidFill>
-                  <a:srgbClr val="D62828"/>
-                </a:solidFill>
-                <a:latin typeface="Arial"/>
-              </a:rPr>
-              <a:t> </a:t>
-            </a:r>
-            <a:r>
-              <a:rPr sz="2000" b="1" i="0" dirty="0" err="1">
-                <a:solidFill>
-                  <a:srgbClr val="D62828"/>
-                </a:solidFill>
-                <a:latin typeface="Arial"/>
-              </a:rPr>
-              <a:t>Punkt</a:t>
-            </a:r>
-            <a:r>
-              <a:rPr sz="2000" b="1" i="0" dirty="0">
-                <a:solidFill>
-                  <a:srgbClr val="D62828"/>
-                </a:solidFill>
-                <a:latin typeface="Arial"/>
-              </a:rPr>
-              <a:t> auf </a:t>
-            </a:r>
-            <a:r>
-              <a:rPr sz="2000" b="1" i="0" dirty="0" err="1">
-                <a:solidFill>
-                  <a:srgbClr val="D62828"/>
-                </a:solidFill>
-                <a:latin typeface="Arial"/>
-              </a:rPr>
-              <a:t>dieser</a:t>
-            </a:r>
-            <a:r>
-              <a:rPr sz="2000" b="1" i="0" dirty="0">
-                <a:solidFill>
-                  <a:srgbClr val="D62828"/>
-                </a:solidFill>
-                <a:latin typeface="Arial"/>
-              </a:rPr>
-              <a:t> Waage.</a:t>
-            </a:r>
-          </a:p>
-        </p:txBody>
-      </p:sp>
-      <p:sp>
-        <p:nvSpPr>
-          <p:cNvPr id="8" name="TextBox 7"/>
-          <p:cNvSpPr txBox="1"/>
-          <p:nvPr/>
-        </p:nvSpPr>
-        <p:spPr>
-          <a:xfrm>
-            <a:off x="822960" y="4892040"/>
-            <a:ext cx="10607040" cy="914400"/>
-          </a:xfrm>
-          <a:prstGeom prst="rect">
-            <a:avLst/>
-          </a:prstGeom>
-          <a:noFill/>
-        </p:spPr>
-        <p:txBody>
-          <a:bodyPr wrap="square" lIns="0" tIns="0" rIns="0" bIns="0" anchor="t">
-            <a:spAutoFit/>
-          </a:bodyPr>
-          <a:lstStyle/>
-          <a:p>
-            <a:pPr algn="l">
-              <a:spcBef>
-                <a:spcPts val="0"/>
-              </a:spcBef>
-              <a:spcAft>
-                <a:spcPts val="400"/>
-              </a:spcAft>
-            </a:pPr>
-            <a:r>
-              <a:rPr sz="1600" b="1" i="0" dirty="0" err="1">
-                <a:solidFill>
-                  <a:srgbClr val="6C7A89"/>
-                </a:solidFill>
-                <a:latin typeface="Arial"/>
-              </a:rPr>
-              <a:t>Untersucht</a:t>
-            </a:r>
-            <a:r>
-              <a:rPr sz="1600" b="1" i="0" dirty="0">
-                <a:solidFill>
-                  <a:srgbClr val="6C7A89"/>
-                </a:solidFill>
-                <a:latin typeface="Arial"/>
-              </a:rPr>
-              <a:t>:</a:t>
-            </a:r>
-          </a:p>
-          <a:p>
-            <a:pPr algn="l">
-              <a:spcBef>
-                <a:spcPts val="0"/>
-              </a:spcBef>
-              <a:spcAft>
-                <a:spcPts val="600"/>
-              </a:spcAft>
-            </a:pPr>
-            <a:r>
-              <a:rPr sz="2000" b="1" i="0" dirty="0" err="1">
-                <a:solidFill>
-                  <a:srgbClr val="1A2332"/>
-                </a:solidFill>
-                <a:latin typeface="Arial"/>
-              </a:rPr>
-              <a:t>Rechteck</a:t>
-            </a:r>
-            <a:r>
-              <a:rPr sz="2000" b="1" i="0" dirty="0">
-                <a:solidFill>
-                  <a:srgbClr val="1A2332"/>
-                </a:solidFill>
-                <a:latin typeface="Arial"/>
-              </a:rPr>
-              <a:t>   ·   Hann   ·   Hamming   ·   Blackman   ·   Kaiser   ·   Flat-Top</a:t>
-            </a:r>
-          </a:p>
-        </p:txBody>
-      </p:sp>
+        </p:spPr>
+      </p:pic>
     </p:spTree>
   </p:cSld>
   <p:clrMapOvr>
@@ -11382,17 +8955,15 @@
 <file path=ppt/slides/slide5.xml><?xml version="1.0" encoding="utf-8"?>
 <p:sld xmlns:a="http://schemas.openxmlformats.org/drawingml/2006/main" xmlns:r="http://schemas.openxmlformats.org/officeDocument/2006/relationships" xmlns:p="http://schemas.openxmlformats.org/presentationml/2006/main">
   <p:cSld>
-    <p:bg>
-      <p:bgPr>
-        <a:solidFill>
-          <a:srgbClr val="1A2332"/>
-        </a:solidFill>
-        <a:effectLst/>
-      </p:bgPr>
-    </p:bg>
     <p:spTree>
       <p:nvGrpSpPr>
-        <p:cNvPr id="1" name=""/>
+        <p:cNvPr id="1" name="">
+          <a:extLst>
+            <a:ext uri="{FF2B5EF4-FFF2-40B4-BE49-F238E27FC236}">
+              <a16:creationId xmlns:a16="http://schemas.microsoft.com/office/drawing/2014/main" id="{5CDA9D6E-FEB5-CB3A-070E-D4BFE12A6843}"/>
+            </a:ext>
+          </a:extLst>
+        </p:cNvPr>
         <p:cNvGrpSpPr/>
         <p:nvPr/>
       </p:nvGrpSpPr>
@@ -11406,59 +8977,20 @@
       </p:grpSpPr>
       <p:sp>
         <p:nvSpPr>
-          <p:cNvPr id="2" name="Rectangle 1"/>
-          <p:cNvSpPr/>
+          <p:cNvPr id="2" name="TextBox 1">
+            <a:extLst>
+              <a:ext uri="{FF2B5EF4-FFF2-40B4-BE49-F238E27FC236}">
+                <a16:creationId xmlns:a16="http://schemas.microsoft.com/office/drawing/2014/main" id="{D4B861B2-4F57-5458-8D03-C75FAC7CDA4B}"/>
+              </a:ext>
+            </a:extLst>
+          </p:cNvPr>
+          <p:cNvSpPr txBox="1"/>
           <p:nvPr/>
         </p:nvSpPr>
         <p:spPr>
           <a:xfrm>
-            <a:off x="822960" y="868680"/>
-            <a:ext cx="1280160" cy="100584"/>
-          </a:xfrm>
-          <a:prstGeom prst="rect">
-            <a:avLst/>
-          </a:prstGeom>
-          <a:solidFill>
-            <a:srgbClr val="D62828"/>
-          </a:solidFill>
-          <a:ln>
-            <a:noFill/>
-          </a:ln>
-          <a:effectLst/>
-        </p:spPr>
-        <p:style>
-          <a:lnRef idx="1">
-            <a:schemeClr val="accent1"/>
-          </a:lnRef>
-          <a:fillRef idx="3">
-            <a:schemeClr val="accent1"/>
-          </a:fillRef>
-          <a:effectRef idx="2">
-            <a:schemeClr val="accent1"/>
-          </a:effectRef>
-          <a:fontRef idx="minor">
-            <a:schemeClr val="lt1"/>
-          </a:fontRef>
-        </p:style>
-        <p:txBody>
-          <a:bodyPr rtlCol="0" anchor="ctr"/>
-          <a:lstStyle/>
-          <a:p>
-            <a:pPr algn="ctr"/>
-            <a:endParaRPr/>
-          </a:p>
-        </p:txBody>
-      </p:sp>
-      <p:sp>
-        <p:nvSpPr>
-          <p:cNvPr id="3" name="TextBox 2"/>
-          <p:cNvSpPr txBox="1"/>
-          <p:nvPr/>
-        </p:nvSpPr>
-        <p:spPr>
-          <a:xfrm>
-            <a:off x="822960" y="1051560"/>
-            <a:ext cx="10515600" cy="1097280"/>
+            <a:off x="640080" y="502920"/>
+            <a:ext cx="10972800" cy="1005840"/>
           </a:xfrm>
           <a:prstGeom prst="rect">
             <a:avLst/>
@@ -11480,27 +9012,84 @@
               </a:spcAft>
             </a:pPr>
             <a:r>
-              <a:rPr sz="4600" b="1" i="0">
+              <a:rPr sz="3000" b="1" i="0">
                 <a:solidFill>
-                  <a:srgbClr val="FFFFFF"/>
+                  <a:srgbClr val="1A2332"/>
                 </a:solidFill>
                 <a:latin typeface="Arial"/>
               </a:rPr>
-              <a:t>LIVE-DEMO</a:t>
+              <a:t>Was wir sehen</a:t>
             </a:r>
           </a:p>
         </p:txBody>
       </p:sp>
       <p:sp>
         <p:nvSpPr>
-          <p:cNvPr id="4" name="TextBox 3"/>
+          <p:cNvPr id="3" name="Rectangle 2">
+            <a:extLst>
+              <a:ext uri="{FF2B5EF4-FFF2-40B4-BE49-F238E27FC236}">
+                <a16:creationId xmlns:a16="http://schemas.microsoft.com/office/drawing/2014/main" id="{F3677843-D818-0C08-8187-0F44FDB6F53F}"/>
+              </a:ext>
+            </a:extLst>
+          </p:cNvPr>
+          <p:cNvSpPr/>
+          <p:nvPr/>
+        </p:nvSpPr>
+        <p:spPr>
+          <a:xfrm>
+            <a:off x="658368" y="1170432"/>
+            <a:ext cx="1005840" cy="82296"/>
+          </a:xfrm>
+          <a:prstGeom prst="rect">
+            <a:avLst/>
+          </a:prstGeom>
+          <a:solidFill>
+            <a:srgbClr val="D62828"/>
+          </a:solidFill>
+          <a:ln>
+            <a:noFill/>
+          </a:ln>
+          <a:effectLst/>
+        </p:spPr>
+        <p:style>
+          <a:lnRef idx="1">
+            <a:schemeClr val="accent1"/>
+          </a:lnRef>
+          <a:fillRef idx="3">
+            <a:schemeClr val="accent1"/>
+          </a:fillRef>
+          <a:effectRef idx="2">
+            <a:schemeClr val="accent1"/>
+          </a:effectRef>
+          <a:fontRef idx="minor">
+            <a:schemeClr val="lt1"/>
+          </a:fontRef>
+        </p:style>
+        <p:txBody>
+          <a:bodyPr rtlCol="0" anchor="ctr"/>
+          <a:lstStyle/>
+          <a:p>
+            <a:pPr algn="ctr"/>
+            <a:endParaRPr/>
+          </a:p>
+        </p:txBody>
+      </p:sp>
+      <p:sp>
+        <p:nvSpPr>
+          <p:cNvPr id="4" name="TextBox 3">
+            <a:extLst>
+              <a:ext uri="{FF2B5EF4-FFF2-40B4-BE49-F238E27FC236}">
+                <a16:creationId xmlns:a16="http://schemas.microsoft.com/office/drawing/2014/main" id="{6602EF99-55B3-59DB-565F-B4125AEE5009}"/>
+              </a:ext>
+            </a:extLst>
+          </p:cNvPr>
           <p:cNvSpPr txBox="1"/>
           <p:nvPr/>
         </p:nvSpPr>
         <p:spPr>
           <a:xfrm>
-            <a:off x="822960" y="1965960"/>
-            <a:ext cx="10607040" cy="548640"/>
+            <a:off x="822960" y="1874519"/>
+            <a:ext cx="10607040" cy="307777"/>
           </a:xfrm>
           <a:prstGeom prst="rect">
             <a:avLst/>
@@ -11522,18 +9111,362 @@
               </a:spcAft>
             </a:pPr>
             <a:r>
-              <a:rPr sz="1800" b="0" i="0">
+              <a:rPr sz="2000" b="0" i="0" dirty="0">
                 <a:solidFill>
-                  <a:srgbClr val="B8C2CC"/>
+                  <a:srgbClr val="1A2332"/>
                 </a:solidFill>
                 <a:latin typeface="Arial"/>
               </a:rPr>
-              <a:t>MATLAB: Code-Struktur &amp; Ergebnisse</a:t>
+              <a:t>Leakage </a:t>
+            </a:r>
+            <a:r>
+              <a:rPr sz="2000" b="0" i="0" dirty="0" err="1">
+                <a:solidFill>
+                  <a:srgbClr val="1A2332"/>
+                </a:solidFill>
+                <a:latin typeface="Arial"/>
+              </a:rPr>
+              <a:t>bläht</a:t>
+            </a:r>
+            <a:r>
+              <a:rPr sz="2000" b="0" i="0" dirty="0">
+                <a:solidFill>
+                  <a:srgbClr val="1A2332"/>
+                </a:solidFill>
+                <a:latin typeface="Arial"/>
+              </a:rPr>
+              <a:t> das </a:t>
+            </a:r>
+            <a:r>
+              <a:rPr sz="2000" b="0" i="0" dirty="0" err="1">
+                <a:solidFill>
+                  <a:srgbClr val="1A2332"/>
+                </a:solidFill>
+                <a:latin typeface="Arial"/>
+              </a:rPr>
+              <a:t>schwache</a:t>
+            </a:r>
+            <a:r>
+              <a:rPr sz="2000" b="0" i="0" dirty="0">
+                <a:solidFill>
+                  <a:srgbClr val="1A2332"/>
+                </a:solidFill>
+                <a:latin typeface="Arial"/>
+              </a:rPr>
+              <a:t> HF-Band auf.</a:t>
+            </a:r>
+            <a:r>
+              <a:rPr lang="de-DE" sz="2000" b="0" i="0" dirty="0">
+                <a:solidFill>
+                  <a:srgbClr val="1A2332"/>
+                </a:solidFill>
+                <a:latin typeface="Arial"/>
+              </a:rPr>
+              <a:t> Dieselbe Messung, nur ein anderes Fenster:</a:t>
+            </a:r>
+            <a:endParaRPr sz="2000" b="0" i="0" dirty="0">
+              <a:solidFill>
+                <a:srgbClr val="1A2332"/>
+              </a:solidFill>
+              <a:latin typeface="Arial"/>
+            </a:endParaRPr>
+          </a:p>
+        </p:txBody>
+      </p:sp>
+      <p:sp>
+        <p:nvSpPr>
+          <p:cNvPr id="5" name="Rounded Rectangle 4">
+            <a:extLst>
+              <a:ext uri="{FF2B5EF4-FFF2-40B4-BE49-F238E27FC236}">
+                <a16:creationId xmlns:a16="http://schemas.microsoft.com/office/drawing/2014/main" id="{5162A21D-96A6-6823-B517-58B16260A024}"/>
+              </a:ext>
+            </a:extLst>
+          </p:cNvPr>
+          <p:cNvSpPr/>
+          <p:nvPr/>
+        </p:nvSpPr>
+        <p:spPr>
+          <a:xfrm>
+            <a:off x="822960" y="2971800"/>
+            <a:ext cx="3291840" cy="1371600"/>
+          </a:xfrm>
+          <a:prstGeom prst="roundRect">
+            <a:avLst/>
+          </a:prstGeom>
+          <a:solidFill>
+            <a:srgbClr val="F4F6F8"/>
+          </a:solidFill>
+          <a:ln w="19050">
+            <a:solidFill>
+              <a:srgbClr val="D62828"/>
+            </a:solidFill>
+          </a:ln>
+          <a:effectLst/>
+        </p:spPr>
+        <p:style>
+          <a:lnRef idx="1">
+            <a:schemeClr val="accent1"/>
+          </a:lnRef>
+          <a:fillRef idx="3">
+            <a:schemeClr val="accent1"/>
+          </a:fillRef>
+          <a:effectRef idx="2">
+            <a:schemeClr val="accent1"/>
+          </a:effectRef>
+          <a:fontRef idx="minor">
+            <a:schemeClr val="lt1"/>
+          </a:fontRef>
+        </p:style>
+        <p:txBody>
+          <a:bodyPr wrap="square" lIns="73152" tIns="36576" rIns="73152" bIns="36576" rtlCol="0" anchor="ctr"/>
+          <a:lstStyle/>
+          <a:p>
+            <a:pPr algn="ctr">
+              <a:spcBef>
+                <a:spcPts val="0"/>
+              </a:spcBef>
+              <a:spcAft>
+                <a:spcPts val="0"/>
+              </a:spcAft>
+            </a:pPr>
+            <a:r>
+              <a:rPr sz="1700" b="1" i="0">
+                <a:solidFill>
+                  <a:srgbClr val="1A2332"/>
+                </a:solidFill>
+                <a:latin typeface="Arial"/>
+              </a:rPr>
+              <a:t>Rechteck
+HF ≈ 31 ms²
+LF/HF = 3,4</a:t>
+            </a:r>
+          </a:p>
+        </p:txBody>
+      </p:sp>
+      <p:sp>
+        <p:nvSpPr>
+          <p:cNvPr id="6" name="Right Arrow 5">
+            <a:extLst>
+              <a:ext uri="{FF2B5EF4-FFF2-40B4-BE49-F238E27FC236}">
+                <a16:creationId xmlns:a16="http://schemas.microsoft.com/office/drawing/2014/main" id="{3D702AC9-1D8D-575F-B877-356B6494A077}"/>
+              </a:ext>
+            </a:extLst>
+          </p:cNvPr>
+          <p:cNvSpPr/>
+          <p:nvPr/>
+        </p:nvSpPr>
+        <p:spPr>
+          <a:xfrm>
+            <a:off x="4343400" y="3520440"/>
+            <a:ext cx="502920" cy="292608"/>
+          </a:xfrm>
+          <a:prstGeom prst="rightArrow">
+            <a:avLst/>
+          </a:prstGeom>
+          <a:solidFill>
+            <a:srgbClr val="6C7A89"/>
+          </a:solidFill>
+          <a:ln>
+            <a:noFill/>
+          </a:ln>
+          <a:effectLst/>
+        </p:spPr>
+        <p:style>
+          <a:lnRef idx="1">
+            <a:schemeClr val="accent1"/>
+          </a:lnRef>
+          <a:fillRef idx="3">
+            <a:schemeClr val="accent1"/>
+          </a:fillRef>
+          <a:effectRef idx="2">
+            <a:schemeClr val="accent1"/>
+          </a:effectRef>
+          <a:fontRef idx="minor">
+            <a:schemeClr val="lt1"/>
+          </a:fontRef>
+        </p:style>
+        <p:txBody>
+          <a:bodyPr rtlCol="0" anchor="ctr"/>
+          <a:lstStyle/>
+          <a:p>
+            <a:pPr algn="ctr"/>
+            <a:endParaRPr/>
+          </a:p>
+        </p:txBody>
+      </p:sp>
+      <p:sp>
+        <p:nvSpPr>
+          <p:cNvPr id="7" name="Rounded Rectangle 6">
+            <a:extLst>
+              <a:ext uri="{FF2B5EF4-FFF2-40B4-BE49-F238E27FC236}">
+                <a16:creationId xmlns:a16="http://schemas.microsoft.com/office/drawing/2014/main" id="{5D7C3F74-87A9-E60C-FAC1-142011FCC5CF}"/>
+              </a:ext>
+            </a:extLst>
+          </p:cNvPr>
+          <p:cNvSpPr/>
+          <p:nvPr/>
+        </p:nvSpPr>
+        <p:spPr>
+          <a:xfrm>
+            <a:off x="5120640" y="2971800"/>
+            <a:ext cx="3291840" cy="1371600"/>
+          </a:xfrm>
+          <a:prstGeom prst="roundRect">
+            <a:avLst/>
+          </a:prstGeom>
+          <a:solidFill>
+            <a:srgbClr val="F4F6F8"/>
+          </a:solidFill>
+          <a:ln w="19050">
+            <a:solidFill>
+              <a:srgbClr val="1A2332"/>
+            </a:solidFill>
+          </a:ln>
+          <a:effectLst/>
+        </p:spPr>
+        <p:style>
+          <a:lnRef idx="1">
+            <a:schemeClr val="accent1"/>
+          </a:lnRef>
+          <a:fillRef idx="3">
+            <a:schemeClr val="accent1"/>
+          </a:fillRef>
+          <a:effectRef idx="2">
+            <a:schemeClr val="accent1"/>
+          </a:effectRef>
+          <a:fontRef idx="minor">
+            <a:schemeClr val="lt1"/>
+          </a:fontRef>
+        </p:style>
+        <p:txBody>
+          <a:bodyPr wrap="square" lIns="73152" tIns="36576" rIns="73152" bIns="36576" rtlCol="0" anchor="ctr"/>
+          <a:lstStyle/>
+          <a:p>
+            <a:pPr algn="ctr">
+              <a:spcBef>
+                <a:spcPts val="0"/>
+              </a:spcBef>
+              <a:spcAft>
+                <a:spcPts val="0"/>
+              </a:spcAft>
+            </a:pPr>
+            <a:r>
+              <a:rPr sz="1700" b="1" i="0">
+                <a:solidFill>
+                  <a:srgbClr val="1A2332"/>
+                </a:solidFill>
+                <a:latin typeface="Arial"/>
+              </a:rPr>
+              <a:t>Flat-Top
+HF ≈ 8 ms²
+LF/HF = 5,5</a:t>
+            </a:r>
+          </a:p>
+        </p:txBody>
+      </p:sp>
+      <p:sp>
+        <p:nvSpPr>
+          <p:cNvPr id="8" name="TextBox 7">
+            <a:extLst>
+              <a:ext uri="{FF2B5EF4-FFF2-40B4-BE49-F238E27FC236}">
+                <a16:creationId xmlns:a16="http://schemas.microsoft.com/office/drawing/2014/main" id="{2081E758-18C8-2AB2-23FC-29E21BD650FA}"/>
+              </a:ext>
+            </a:extLst>
+          </p:cNvPr>
+          <p:cNvSpPr txBox="1"/>
+          <p:nvPr/>
+        </p:nvSpPr>
+        <p:spPr>
+          <a:xfrm>
+            <a:off x="8686800" y="2971800"/>
+            <a:ext cx="2743200" cy="1371600"/>
+          </a:xfrm>
+          <a:prstGeom prst="rect">
+            <a:avLst/>
+          </a:prstGeom>
+          <a:noFill/>
+        </p:spPr>
+        <p:txBody>
+          <a:bodyPr wrap="square" lIns="0" tIns="0" rIns="0" bIns="0" anchor="ctr">
+            <a:spAutoFit/>
+          </a:bodyPr>
+          <a:lstStyle/>
+          <a:p>
+            <a:pPr algn="ctr">
+              <a:spcBef>
+                <a:spcPts val="0"/>
+              </a:spcBef>
+              <a:spcAft>
+                <a:spcPts val="600"/>
+              </a:spcAft>
+            </a:pPr>
+            <a:r>
+              <a:rPr sz="2000" b="1" i="0">
+                <a:solidFill>
+                  <a:srgbClr val="D62828"/>
+                </a:solidFill>
+                <a:latin typeface="Arial"/>
+              </a:rPr>
+              <a:t>≈ 4×
+Unterschied!</a:t>
+            </a:r>
+          </a:p>
+        </p:txBody>
+      </p:sp>
+      <p:sp>
+        <p:nvSpPr>
+          <p:cNvPr id="9" name="TextBox 8">
+            <a:extLst>
+              <a:ext uri="{FF2B5EF4-FFF2-40B4-BE49-F238E27FC236}">
+                <a16:creationId xmlns:a16="http://schemas.microsoft.com/office/drawing/2014/main" id="{80375380-78D7-C9E5-E9DC-A269253F8E68}"/>
+              </a:ext>
+            </a:extLst>
+          </p:cNvPr>
+          <p:cNvSpPr txBox="1"/>
+          <p:nvPr/>
+        </p:nvSpPr>
+        <p:spPr>
+          <a:xfrm>
+            <a:off x="822960" y="4892040"/>
+            <a:ext cx="10607040" cy="822960"/>
+          </a:xfrm>
+          <a:prstGeom prst="rect">
+            <a:avLst/>
+          </a:prstGeom>
+          <a:noFill/>
+        </p:spPr>
+        <p:txBody>
+          <a:bodyPr wrap="square" lIns="0" tIns="0" rIns="0" bIns="0" anchor="t">
+            <a:spAutoFit/>
+          </a:bodyPr>
+          <a:lstStyle/>
+          <a:p>
+            <a:pPr algn="l">
+              <a:spcBef>
+                <a:spcPts val="0"/>
+              </a:spcBef>
+              <a:spcAft>
+                <a:spcPts val="600"/>
+              </a:spcAft>
+            </a:pPr>
+            <a:r>
+              <a:rPr sz="1900" b="1" i="0">
+                <a:solidFill>
+                  <a:srgbClr val="D62828"/>
+                </a:solidFill>
+                <a:latin typeface="Arial"/>
+              </a:rPr>
+              <a:t>Falsches Fenster = falscher Kennwert. Ein leaky Fenster kann sogar das klinisch genutzte LF/HF-Verhältnis verzerren.</a:t>
             </a:r>
           </a:p>
         </p:txBody>
       </p:sp>
     </p:spTree>
+    <p:extLst>
+      <p:ext uri="{BB962C8B-B14F-4D97-AF65-F5344CB8AC3E}">
+        <p14:creationId xmlns:p14="http://schemas.microsoft.com/office/powerpoint/2010/main" val="3477102263"/>
+      </p:ext>
+    </p:extLst>
   </p:cSld>
   <p:clrMapOvr>
     <a:masterClrMapping/>
@@ -11575,708 +9508,6 @@
         <p:spPr>
           <a:xfrm>
             <a:off x="640080" y="502920"/>
-            <a:ext cx="10972800" cy="461665"/>
-          </a:xfrm>
-          <a:prstGeom prst="rect">
-            <a:avLst/>
-          </a:prstGeom>
-          <a:noFill/>
-        </p:spPr>
-        <p:txBody>
-          <a:bodyPr wrap="square" lIns="0" tIns="0" rIns="0" bIns="0" anchor="t">
-            <a:spAutoFit/>
-          </a:bodyPr>
-          <a:lstStyle/>
-          <a:p>
-            <a:pPr algn="l">
-              <a:spcBef>
-                <a:spcPts val="0"/>
-              </a:spcBef>
-              <a:spcAft>
-                <a:spcPts val="0"/>
-              </a:spcAft>
-            </a:pPr>
-            <a:r>
-              <a:rPr lang="de-DE" sz="3000" b="1" i="0" dirty="0">
-                <a:solidFill>
-                  <a:srgbClr val="1A2332"/>
-                </a:solidFill>
-                <a:latin typeface="Arial"/>
-              </a:rPr>
-              <a:t>Hauptkeulenunterschied</a:t>
-            </a:r>
-          </a:p>
-        </p:txBody>
-      </p:sp>
-      <p:sp>
-        <p:nvSpPr>
-          <p:cNvPr id="3" name="Rectangle 2"/>
-          <p:cNvSpPr/>
-          <p:nvPr/>
-        </p:nvSpPr>
-        <p:spPr>
-          <a:xfrm>
-            <a:off x="658368" y="1170432"/>
-            <a:ext cx="1005840" cy="82296"/>
-          </a:xfrm>
-          <a:prstGeom prst="rect">
-            <a:avLst/>
-          </a:prstGeom>
-          <a:solidFill>
-            <a:srgbClr val="D62828"/>
-          </a:solidFill>
-          <a:ln>
-            <a:noFill/>
-          </a:ln>
-          <a:effectLst/>
-        </p:spPr>
-        <p:style>
-          <a:lnRef idx="1">
-            <a:schemeClr val="accent1"/>
-          </a:lnRef>
-          <a:fillRef idx="3">
-            <a:schemeClr val="accent1"/>
-          </a:fillRef>
-          <a:effectRef idx="2">
-            <a:schemeClr val="accent1"/>
-          </a:effectRef>
-          <a:fontRef idx="minor">
-            <a:schemeClr val="lt1"/>
-          </a:fontRef>
-        </p:style>
-        <p:txBody>
-          <a:bodyPr rtlCol="0" anchor="ctr"/>
-          <a:lstStyle/>
-          <a:p>
-            <a:pPr algn="ctr"/>
-            <a:endParaRPr/>
-          </a:p>
-        </p:txBody>
-      </p:sp>
-      <p:pic>
-        <p:nvPicPr>
-          <p:cNvPr id="10" name="Grafik 9">
-            <a:extLst>
-              <a:ext uri="{FF2B5EF4-FFF2-40B4-BE49-F238E27FC236}">
-                <a16:creationId xmlns:a16="http://schemas.microsoft.com/office/drawing/2014/main" id="{6E0C536B-7D84-20F0-EF43-1251F42B5C60}"/>
-              </a:ext>
-            </a:extLst>
-          </p:cNvPr>
-          <p:cNvPicPr>
-            <a:picLocks noChangeAspect="1"/>
-          </p:cNvPicPr>
-          <p:nvPr/>
-        </p:nvPicPr>
-        <p:blipFill>
-          <a:blip r:embed="rId3"/>
-          <a:stretch>
-            <a:fillRect/>
-          </a:stretch>
-        </p:blipFill>
-        <p:spPr>
-          <a:xfrm>
-            <a:off x="183882" y="1519693"/>
-            <a:ext cx="5786250" cy="3818614"/>
-          </a:xfrm>
-          <a:prstGeom prst="rect">
-            <a:avLst/>
-          </a:prstGeom>
-        </p:spPr>
-      </p:pic>
-      <p:pic>
-        <p:nvPicPr>
-          <p:cNvPr id="11" name="Grafik 10">
-            <a:extLst>
-              <a:ext uri="{FF2B5EF4-FFF2-40B4-BE49-F238E27FC236}">
-                <a16:creationId xmlns:a16="http://schemas.microsoft.com/office/drawing/2014/main" id="{E6E73D98-395F-3ABB-E8E2-5172BDAA8348}"/>
-              </a:ext>
-            </a:extLst>
-          </p:cNvPr>
-          <p:cNvPicPr>
-            <a:picLocks noChangeAspect="1"/>
-          </p:cNvPicPr>
-          <p:nvPr/>
-        </p:nvPicPr>
-        <p:blipFill>
-          <a:blip r:embed="rId4"/>
-          <a:stretch>
-            <a:fillRect/>
-          </a:stretch>
-        </p:blipFill>
-        <p:spPr>
-          <a:xfrm>
-            <a:off x="6096000" y="1540004"/>
-            <a:ext cx="5817360" cy="3798303"/>
-          </a:xfrm>
-          <a:prstGeom prst="rect">
-            <a:avLst/>
-          </a:prstGeom>
-        </p:spPr>
-      </p:pic>
-    </p:spTree>
-  </p:cSld>
-  <p:clrMapOvr>
-    <a:masterClrMapping/>
-  </p:clrMapOvr>
-</p:sld>
-</file>
-
-<file path=ppt/slides/slide7.xml><?xml version="1.0" encoding="utf-8"?>
-<p:sld xmlns:a="http://schemas.openxmlformats.org/drawingml/2006/main" xmlns:r="http://schemas.openxmlformats.org/officeDocument/2006/relationships" xmlns:p="http://schemas.openxmlformats.org/presentationml/2006/main">
-  <p:cSld>
-    <p:spTree>
-      <p:nvGrpSpPr>
-        <p:cNvPr id="1" name="">
-          <a:extLst>
-            <a:ext uri="{FF2B5EF4-FFF2-40B4-BE49-F238E27FC236}">
-              <a16:creationId xmlns:a16="http://schemas.microsoft.com/office/drawing/2014/main" id="{5CDA9D6E-FEB5-CB3A-070E-D4BFE12A6843}"/>
-            </a:ext>
-          </a:extLst>
-        </p:cNvPr>
-        <p:cNvGrpSpPr/>
-        <p:nvPr/>
-      </p:nvGrpSpPr>
-      <p:grpSpPr>
-        <a:xfrm>
-          <a:off x="0" y="0"/>
-          <a:ext cx="0" cy="0"/>
-          <a:chOff x="0" y="0"/>
-          <a:chExt cx="0" cy="0"/>
-        </a:xfrm>
-      </p:grpSpPr>
-      <p:sp>
-        <p:nvSpPr>
-          <p:cNvPr id="2" name="TextBox 1">
-            <a:extLst>
-              <a:ext uri="{FF2B5EF4-FFF2-40B4-BE49-F238E27FC236}">
-                <a16:creationId xmlns:a16="http://schemas.microsoft.com/office/drawing/2014/main" id="{D4B861B2-4F57-5458-8D03-C75FAC7CDA4B}"/>
-              </a:ext>
-            </a:extLst>
-          </p:cNvPr>
-          <p:cNvSpPr txBox="1"/>
-          <p:nvPr/>
-        </p:nvSpPr>
-        <p:spPr>
-          <a:xfrm>
-            <a:off x="640080" y="502920"/>
-            <a:ext cx="10972800" cy="1005840"/>
-          </a:xfrm>
-          <a:prstGeom prst="rect">
-            <a:avLst/>
-          </a:prstGeom>
-          <a:noFill/>
-        </p:spPr>
-        <p:txBody>
-          <a:bodyPr wrap="square" lIns="0" tIns="0" rIns="0" bIns="0" anchor="t">
-            <a:spAutoFit/>
-          </a:bodyPr>
-          <a:lstStyle/>
-          <a:p>
-            <a:pPr algn="l">
-              <a:spcBef>
-                <a:spcPts val="0"/>
-              </a:spcBef>
-              <a:spcAft>
-                <a:spcPts val="0"/>
-              </a:spcAft>
-            </a:pPr>
-            <a:r>
-              <a:rPr sz="3000" b="1" i="0">
-                <a:solidFill>
-                  <a:srgbClr val="1A2332"/>
-                </a:solidFill>
-                <a:latin typeface="Arial"/>
-              </a:rPr>
-              <a:t>Was wir sehen</a:t>
-            </a:r>
-          </a:p>
-        </p:txBody>
-      </p:sp>
-      <p:sp>
-        <p:nvSpPr>
-          <p:cNvPr id="3" name="Rectangle 2">
-            <a:extLst>
-              <a:ext uri="{FF2B5EF4-FFF2-40B4-BE49-F238E27FC236}">
-                <a16:creationId xmlns:a16="http://schemas.microsoft.com/office/drawing/2014/main" id="{F3677843-D818-0C08-8187-0F44FDB6F53F}"/>
-              </a:ext>
-            </a:extLst>
-          </p:cNvPr>
-          <p:cNvSpPr/>
-          <p:nvPr/>
-        </p:nvSpPr>
-        <p:spPr>
-          <a:xfrm>
-            <a:off x="658368" y="1170432"/>
-            <a:ext cx="1005840" cy="82296"/>
-          </a:xfrm>
-          <a:prstGeom prst="rect">
-            <a:avLst/>
-          </a:prstGeom>
-          <a:solidFill>
-            <a:srgbClr val="D62828"/>
-          </a:solidFill>
-          <a:ln>
-            <a:noFill/>
-          </a:ln>
-          <a:effectLst/>
-        </p:spPr>
-        <p:style>
-          <a:lnRef idx="1">
-            <a:schemeClr val="accent1"/>
-          </a:lnRef>
-          <a:fillRef idx="3">
-            <a:schemeClr val="accent1"/>
-          </a:fillRef>
-          <a:effectRef idx="2">
-            <a:schemeClr val="accent1"/>
-          </a:effectRef>
-          <a:fontRef idx="minor">
-            <a:schemeClr val="lt1"/>
-          </a:fontRef>
-        </p:style>
-        <p:txBody>
-          <a:bodyPr rtlCol="0" anchor="ctr"/>
-          <a:lstStyle/>
-          <a:p>
-            <a:pPr algn="ctr"/>
-            <a:endParaRPr/>
-          </a:p>
-        </p:txBody>
-      </p:sp>
-      <p:sp>
-        <p:nvSpPr>
-          <p:cNvPr id="4" name="TextBox 3">
-            <a:extLst>
-              <a:ext uri="{FF2B5EF4-FFF2-40B4-BE49-F238E27FC236}">
-                <a16:creationId xmlns:a16="http://schemas.microsoft.com/office/drawing/2014/main" id="{6602EF99-55B3-59DB-565F-B4125AEE5009}"/>
-              </a:ext>
-            </a:extLst>
-          </p:cNvPr>
-          <p:cNvSpPr txBox="1"/>
-          <p:nvPr/>
-        </p:nvSpPr>
-        <p:spPr>
-          <a:xfrm>
-            <a:off x="822960" y="1874519"/>
-            <a:ext cx="10607040" cy="307777"/>
-          </a:xfrm>
-          <a:prstGeom prst="rect">
-            <a:avLst/>
-          </a:prstGeom>
-          <a:noFill/>
-        </p:spPr>
-        <p:txBody>
-          <a:bodyPr wrap="square" lIns="0" tIns="0" rIns="0" bIns="0" anchor="t">
-            <a:spAutoFit/>
-          </a:bodyPr>
-          <a:lstStyle/>
-          <a:p>
-            <a:pPr algn="l">
-              <a:spcBef>
-                <a:spcPts val="0"/>
-              </a:spcBef>
-              <a:spcAft>
-                <a:spcPts val="600"/>
-              </a:spcAft>
-            </a:pPr>
-            <a:r>
-              <a:rPr sz="2000" b="0" i="0" dirty="0">
-                <a:solidFill>
-                  <a:srgbClr val="1A2332"/>
-                </a:solidFill>
-                <a:latin typeface="Arial"/>
-              </a:rPr>
-              <a:t>Leakage </a:t>
-            </a:r>
-            <a:r>
-              <a:rPr sz="2000" b="0" i="0" dirty="0" err="1">
-                <a:solidFill>
-                  <a:srgbClr val="1A2332"/>
-                </a:solidFill>
-                <a:latin typeface="Arial"/>
-              </a:rPr>
-              <a:t>bläht</a:t>
-            </a:r>
-            <a:r>
-              <a:rPr sz="2000" b="0" i="0" dirty="0">
-                <a:solidFill>
-                  <a:srgbClr val="1A2332"/>
-                </a:solidFill>
-                <a:latin typeface="Arial"/>
-              </a:rPr>
-              <a:t> das </a:t>
-            </a:r>
-            <a:r>
-              <a:rPr sz="2000" b="0" i="0" dirty="0" err="1">
-                <a:solidFill>
-                  <a:srgbClr val="1A2332"/>
-                </a:solidFill>
-                <a:latin typeface="Arial"/>
-              </a:rPr>
-              <a:t>schwache</a:t>
-            </a:r>
-            <a:r>
-              <a:rPr sz="2000" b="0" i="0" dirty="0">
-                <a:solidFill>
-                  <a:srgbClr val="1A2332"/>
-                </a:solidFill>
-                <a:latin typeface="Arial"/>
-              </a:rPr>
-              <a:t> HF-Band auf.</a:t>
-            </a:r>
-            <a:r>
-              <a:rPr lang="de-DE" sz="2000" b="0" i="0" dirty="0">
-                <a:solidFill>
-                  <a:srgbClr val="1A2332"/>
-                </a:solidFill>
-                <a:latin typeface="Arial"/>
-              </a:rPr>
-              <a:t> Dieselbe Messung, nur ein anderes Fenster:</a:t>
-            </a:r>
-            <a:endParaRPr sz="2000" b="0" i="0" dirty="0">
-              <a:solidFill>
-                <a:srgbClr val="1A2332"/>
-              </a:solidFill>
-              <a:latin typeface="Arial"/>
-            </a:endParaRPr>
-          </a:p>
-        </p:txBody>
-      </p:sp>
-      <p:sp>
-        <p:nvSpPr>
-          <p:cNvPr id="5" name="Rounded Rectangle 4">
-            <a:extLst>
-              <a:ext uri="{FF2B5EF4-FFF2-40B4-BE49-F238E27FC236}">
-                <a16:creationId xmlns:a16="http://schemas.microsoft.com/office/drawing/2014/main" id="{5162A21D-96A6-6823-B517-58B16260A024}"/>
-              </a:ext>
-            </a:extLst>
-          </p:cNvPr>
-          <p:cNvSpPr/>
-          <p:nvPr/>
-        </p:nvSpPr>
-        <p:spPr>
-          <a:xfrm>
-            <a:off x="822960" y="2971800"/>
-            <a:ext cx="3291840" cy="1371600"/>
-          </a:xfrm>
-          <a:prstGeom prst="roundRect">
-            <a:avLst/>
-          </a:prstGeom>
-          <a:solidFill>
-            <a:srgbClr val="F4F6F8"/>
-          </a:solidFill>
-          <a:ln w="19050">
-            <a:solidFill>
-              <a:srgbClr val="D62828"/>
-            </a:solidFill>
-          </a:ln>
-          <a:effectLst/>
-        </p:spPr>
-        <p:style>
-          <a:lnRef idx="1">
-            <a:schemeClr val="accent1"/>
-          </a:lnRef>
-          <a:fillRef idx="3">
-            <a:schemeClr val="accent1"/>
-          </a:fillRef>
-          <a:effectRef idx="2">
-            <a:schemeClr val="accent1"/>
-          </a:effectRef>
-          <a:fontRef idx="minor">
-            <a:schemeClr val="lt1"/>
-          </a:fontRef>
-        </p:style>
-        <p:txBody>
-          <a:bodyPr wrap="square" lIns="73152" tIns="36576" rIns="73152" bIns="36576" rtlCol="0" anchor="ctr"/>
-          <a:lstStyle/>
-          <a:p>
-            <a:pPr algn="ctr">
-              <a:spcBef>
-                <a:spcPts val="0"/>
-              </a:spcBef>
-              <a:spcAft>
-                <a:spcPts val="0"/>
-              </a:spcAft>
-            </a:pPr>
-            <a:r>
-              <a:rPr sz="1700" b="1" i="0">
-                <a:solidFill>
-                  <a:srgbClr val="1A2332"/>
-                </a:solidFill>
-                <a:latin typeface="Arial"/>
-              </a:rPr>
-              <a:t>Rechteck
-HF ≈ 31 ms²
-LF/HF = 3,4</a:t>
-            </a:r>
-          </a:p>
-        </p:txBody>
-      </p:sp>
-      <p:sp>
-        <p:nvSpPr>
-          <p:cNvPr id="6" name="Right Arrow 5">
-            <a:extLst>
-              <a:ext uri="{FF2B5EF4-FFF2-40B4-BE49-F238E27FC236}">
-                <a16:creationId xmlns:a16="http://schemas.microsoft.com/office/drawing/2014/main" id="{3D702AC9-1D8D-575F-B877-356B6494A077}"/>
-              </a:ext>
-            </a:extLst>
-          </p:cNvPr>
-          <p:cNvSpPr/>
-          <p:nvPr/>
-        </p:nvSpPr>
-        <p:spPr>
-          <a:xfrm>
-            <a:off x="4343400" y="3520440"/>
-            <a:ext cx="502920" cy="292608"/>
-          </a:xfrm>
-          <a:prstGeom prst="rightArrow">
-            <a:avLst/>
-          </a:prstGeom>
-          <a:solidFill>
-            <a:srgbClr val="6C7A89"/>
-          </a:solidFill>
-          <a:ln>
-            <a:noFill/>
-          </a:ln>
-          <a:effectLst/>
-        </p:spPr>
-        <p:style>
-          <a:lnRef idx="1">
-            <a:schemeClr val="accent1"/>
-          </a:lnRef>
-          <a:fillRef idx="3">
-            <a:schemeClr val="accent1"/>
-          </a:fillRef>
-          <a:effectRef idx="2">
-            <a:schemeClr val="accent1"/>
-          </a:effectRef>
-          <a:fontRef idx="minor">
-            <a:schemeClr val="lt1"/>
-          </a:fontRef>
-        </p:style>
-        <p:txBody>
-          <a:bodyPr rtlCol="0" anchor="ctr"/>
-          <a:lstStyle/>
-          <a:p>
-            <a:pPr algn="ctr"/>
-            <a:endParaRPr/>
-          </a:p>
-        </p:txBody>
-      </p:sp>
-      <p:sp>
-        <p:nvSpPr>
-          <p:cNvPr id="7" name="Rounded Rectangle 6">
-            <a:extLst>
-              <a:ext uri="{FF2B5EF4-FFF2-40B4-BE49-F238E27FC236}">
-                <a16:creationId xmlns:a16="http://schemas.microsoft.com/office/drawing/2014/main" id="{5D7C3F74-87A9-E60C-FAC1-142011FCC5CF}"/>
-              </a:ext>
-            </a:extLst>
-          </p:cNvPr>
-          <p:cNvSpPr/>
-          <p:nvPr/>
-        </p:nvSpPr>
-        <p:spPr>
-          <a:xfrm>
-            <a:off x="5120640" y="2971800"/>
-            <a:ext cx="3291840" cy="1371600"/>
-          </a:xfrm>
-          <a:prstGeom prst="roundRect">
-            <a:avLst/>
-          </a:prstGeom>
-          <a:solidFill>
-            <a:srgbClr val="F4F6F8"/>
-          </a:solidFill>
-          <a:ln w="19050">
-            <a:solidFill>
-              <a:srgbClr val="1A2332"/>
-            </a:solidFill>
-          </a:ln>
-          <a:effectLst/>
-        </p:spPr>
-        <p:style>
-          <a:lnRef idx="1">
-            <a:schemeClr val="accent1"/>
-          </a:lnRef>
-          <a:fillRef idx="3">
-            <a:schemeClr val="accent1"/>
-          </a:fillRef>
-          <a:effectRef idx="2">
-            <a:schemeClr val="accent1"/>
-          </a:effectRef>
-          <a:fontRef idx="minor">
-            <a:schemeClr val="lt1"/>
-          </a:fontRef>
-        </p:style>
-        <p:txBody>
-          <a:bodyPr wrap="square" lIns="73152" tIns="36576" rIns="73152" bIns="36576" rtlCol="0" anchor="ctr"/>
-          <a:lstStyle/>
-          <a:p>
-            <a:pPr algn="ctr">
-              <a:spcBef>
-                <a:spcPts val="0"/>
-              </a:spcBef>
-              <a:spcAft>
-                <a:spcPts val="0"/>
-              </a:spcAft>
-            </a:pPr>
-            <a:r>
-              <a:rPr sz="1700" b="1" i="0">
-                <a:solidFill>
-                  <a:srgbClr val="1A2332"/>
-                </a:solidFill>
-                <a:latin typeface="Arial"/>
-              </a:rPr>
-              <a:t>Flat-Top
-HF ≈ 8 ms²
-LF/HF = 5,5</a:t>
-            </a:r>
-          </a:p>
-        </p:txBody>
-      </p:sp>
-      <p:sp>
-        <p:nvSpPr>
-          <p:cNvPr id="8" name="TextBox 7">
-            <a:extLst>
-              <a:ext uri="{FF2B5EF4-FFF2-40B4-BE49-F238E27FC236}">
-                <a16:creationId xmlns:a16="http://schemas.microsoft.com/office/drawing/2014/main" id="{2081E758-18C8-2AB2-23FC-29E21BD650FA}"/>
-              </a:ext>
-            </a:extLst>
-          </p:cNvPr>
-          <p:cNvSpPr txBox="1"/>
-          <p:nvPr/>
-        </p:nvSpPr>
-        <p:spPr>
-          <a:xfrm>
-            <a:off x="8686800" y="2971800"/>
-            <a:ext cx="2743200" cy="1371600"/>
-          </a:xfrm>
-          <a:prstGeom prst="rect">
-            <a:avLst/>
-          </a:prstGeom>
-          <a:noFill/>
-        </p:spPr>
-        <p:txBody>
-          <a:bodyPr wrap="square" lIns="0" tIns="0" rIns="0" bIns="0" anchor="ctr">
-            <a:spAutoFit/>
-          </a:bodyPr>
-          <a:lstStyle/>
-          <a:p>
-            <a:pPr algn="ctr">
-              <a:spcBef>
-                <a:spcPts val="0"/>
-              </a:spcBef>
-              <a:spcAft>
-                <a:spcPts val="600"/>
-              </a:spcAft>
-            </a:pPr>
-            <a:r>
-              <a:rPr sz="2000" b="1" i="0">
-                <a:solidFill>
-                  <a:srgbClr val="D62828"/>
-                </a:solidFill>
-                <a:latin typeface="Arial"/>
-              </a:rPr>
-              <a:t>≈ 4×
-Unterschied!</a:t>
-            </a:r>
-          </a:p>
-        </p:txBody>
-      </p:sp>
-      <p:sp>
-        <p:nvSpPr>
-          <p:cNvPr id="9" name="TextBox 8">
-            <a:extLst>
-              <a:ext uri="{FF2B5EF4-FFF2-40B4-BE49-F238E27FC236}">
-                <a16:creationId xmlns:a16="http://schemas.microsoft.com/office/drawing/2014/main" id="{80375380-78D7-C9E5-E9DC-A269253F8E68}"/>
-              </a:ext>
-            </a:extLst>
-          </p:cNvPr>
-          <p:cNvSpPr txBox="1"/>
-          <p:nvPr/>
-        </p:nvSpPr>
-        <p:spPr>
-          <a:xfrm>
-            <a:off x="822960" y="4892040"/>
-            <a:ext cx="10607040" cy="822960"/>
-          </a:xfrm>
-          <a:prstGeom prst="rect">
-            <a:avLst/>
-          </a:prstGeom>
-          <a:noFill/>
-        </p:spPr>
-        <p:txBody>
-          <a:bodyPr wrap="square" lIns="0" tIns="0" rIns="0" bIns="0" anchor="t">
-            <a:spAutoFit/>
-          </a:bodyPr>
-          <a:lstStyle/>
-          <a:p>
-            <a:pPr algn="l">
-              <a:spcBef>
-                <a:spcPts val="0"/>
-              </a:spcBef>
-              <a:spcAft>
-                <a:spcPts val="600"/>
-              </a:spcAft>
-            </a:pPr>
-            <a:r>
-              <a:rPr sz="1900" b="1" i="0">
-                <a:solidFill>
-                  <a:srgbClr val="D62828"/>
-                </a:solidFill>
-                <a:latin typeface="Arial"/>
-              </a:rPr>
-              <a:t>Falsches Fenster = falscher Kennwert. Ein leaky Fenster kann sogar das klinisch genutzte LF/HF-Verhältnis verzerren.</a:t>
-            </a:r>
-          </a:p>
-        </p:txBody>
-      </p:sp>
-    </p:spTree>
-    <p:extLst>
-      <p:ext uri="{BB962C8B-B14F-4D97-AF65-F5344CB8AC3E}">
-        <p14:creationId xmlns:p14="http://schemas.microsoft.com/office/powerpoint/2010/main" val="3477102263"/>
-      </p:ext>
-    </p:extLst>
-  </p:cSld>
-  <p:clrMapOvr>
-    <a:masterClrMapping/>
-  </p:clrMapOvr>
-</p:sld>
-</file>
-
-<file path=ppt/slides/slide8.xml><?xml version="1.0" encoding="utf-8"?>
-<p:sld xmlns:a="http://schemas.openxmlformats.org/drawingml/2006/main" xmlns:r="http://schemas.openxmlformats.org/officeDocument/2006/relationships" xmlns:p="http://schemas.openxmlformats.org/presentationml/2006/main">
-  <p:cSld>
-    <p:bg>
-      <p:bgPr>
-        <a:solidFill>
-          <a:srgbClr val="FFFFFF"/>
-        </a:solidFill>
-        <a:effectLst/>
-      </p:bgPr>
-    </p:bg>
-    <p:spTree>
-      <p:nvGrpSpPr>
-        <p:cNvPr id="1" name=""/>
-        <p:cNvGrpSpPr/>
-        <p:nvPr/>
-      </p:nvGrpSpPr>
-      <p:grpSpPr>
-        <a:xfrm>
-          <a:off x="0" y="0"/>
-          <a:ext cx="0" cy="0"/>
-          <a:chOff x="0" y="0"/>
-          <a:chExt cx="0" cy="0"/>
-        </a:xfrm>
-      </p:grpSpPr>
-      <p:sp>
-        <p:nvSpPr>
-          <p:cNvPr id="2" name="TextBox 1"/>
-          <p:cNvSpPr txBox="1"/>
-          <p:nvPr/>
-        </p:nvSpPr>
-        <p:spPr>
-          <a:xfrm>
-            <a:off x="640080" y="502920"/>
             <a:ext cx="10972800" cy="1005840"/>
           </a:xfrm>
           <a:prstGeom prst="rect">
@@ -12967,7 +10198,7 @@
 </p:sld>
 </file>
 
-<file path=ppt/slides/slide9.xml><?xml version="1.0" encoding="utf-8"?>
+<file path=ppt/slides/slide7.xml><?xml version="1.0" encoding="utf-8"?>
 <p:sld xmlns:a="http://schemas.openxmlformats.org/drawingml/2006/main" xmlns:r="http://schemas.openxmlformats.org/officeDocument/2006/relationships" xmlns:p="http://schemas.openxmlformats.org/presentationml/2006/main">
   <p:cSld>
     <p:bg>

</xml_diff>